<commit_message>
Put every slide on Sabio slide masters (SABIO_CONTENT, SABIO_COVER) and re-render this week's decks
Co-Authored-By: Claude Opus 5.5 <noreply@anthropic.com>
Claude-Session: https://claude.ai/code/session_0185jYuYA7Ra9MSPnj515kfg
</commit_message>
<xml_diff>
--- a/weeks/2026-10-19/decks/Sabio_DICKS_Holiday_Two_Banners_10.19.26.pptx
+++ b/weeks/2026-10-19/decks/Sabio_DICKS_Holiday_Two_Banners_10.19.26.pptx
@@ -1375,6 +1375,220 @@
 </p:sldLayout>
 </file>
 
+<file path=ppt/slideLayouts/slideLayout2.xml><?xml version="1.0" encoding="utf-8"?>
+<p:sldLayout xmlns:a="http://schemas.openxmlformats.org/drawingml/2006/main" xmlns:r="http://schemas.openxmlformats.org/officeDocument/2006/relationships" xmlns:p="http://schemas.openxmlformats.org/presentationml/2006/main" preserve="1">
+  <p:cSld name="SABIO_CONTENT">
+    <p:bg>
+      <p:bgPr>
+        <a:solidFill>
+          <a:srgbClr val="1A1A1A"/>
+        </a:solidFill>
+      </p:bgPr>
+    </p:bg>
+    <p:spTree>
+      <p:nvGrpSpPr>
+        <p:cNvPr id="1" name=""/>
+        <p:cNvGrpSpPr/>
+        <p:nvPr/>
+      </p:nvGrpSpPr>
+      <p:grpSpPr>
+        <a:xfrm>
+          <a:off x="0" y="0"/>
+          <a:ext cx="0" cy="0"/>
+          <a:chOff x="0" y="0"/>
+          <a:chExt cx="0" cy="0"/>
+        </a:xfrm>
+      </p:grpSpPr>
+      <p:pic>
+        <p:nvPicPr>
+          <p:cNvPr id="2" name="Image 0" descr="/home/claude/sabio-deck-builders-/assets/sabio-logo-white-sm.png">    </p:cNvPr>
+          <p:cNvPicPr>
+            <a:picLocks noChangeAspect="1"/>
+          </p:cNvPicPr>
+          <p:nvPr/>
+        </p:nvPicPr>
+        <p:blipFill>
+          <a:blip r:embed="rId1"/>
+          <a:stretch>
+            <a:fillRect/>
+          </a:stretch>
+        </p:blipFill>
+        <p:spPr>
+          <a:xfrm>
+            <a:off x="8028432" y="4805172"/>
+            <a:ext cx="647572" cy="155448"/>
+          </a:xfrm>
+          <a:prstGeom prst="rect">
+            <a:avLst/>
+          </a:prstGeom>
+        </p:spPr>
+      </p:pic>
+      <p:sp>
+        <p:nvSpPr>
+          <p:cNvPr id="3" name="Text 0"/>
+          <p:cNvSpPr/>
+          <p:nvPr/>
+        </p:nvSpPr>
+        <p:spPr>
+          <a:xfrm>
+            <a:off x="868680" y="4832604"/>
+            <a:ext cx="5486400" cy="182880"/>
+          </a:xfrm>
+          <a:prstGeom prst="rect">
+            <a:avLst/>
+          </a:prstGeom>
+          <a:noFill/>
+          <a:ln/>
+        </p:spPr>
+        <p:txBody>
+          <a:bodyPr wrap="square" lIns="0" tIns="0" rIns="0" bIns="0" rtlCol="0" anchor="t"/>
+          <a:lstStyle/>
+          <a:p>
+            <a:pPr indent="0" marL="0">
+              <a:buNone/>
+            </a:pPr>
+            <a:r>
+              <a:rPr lang="en-US" sz="700" dirty="0">
+                <a:solidFill>
+                  <a:srgbClr val="7E7E7E"/>
+                </a:solidFill>
+                <a:latin typeface="Poppins" pitchFamily="34" charset="0"/>
+                <a:ea typeface="Poppins" pitchFamily="34" charset="-122"/>
+                <a:cs typeface="Poppins" pitchFamily="34" charset="-120"/>
+              </a:rPr>
+              <a:t>Sabio × DICK'S  ·  Proactive point of view for Zenith  ·  Confidential</a:t>
+            </a:r>
+            <a:endParaRPr lang="en-US" sz="700" dirty="0"/>
+          </a:p>
+        </p:txBody>
+      </p:sp>
+      <p:sp>
+        <p:nvSpPr>
+          <p:cNvPr id="25" name="Slide Number Placeholder 0"/>
+          <p:cNvSpPr>
+            <a:spLocks noGrp="1"/>
+          </p:cNvSpPr>
+          <p:nvPr>
+            <p:ph type="sldNum" sz="quarter" idx="4294967295"/>
+          </p:nvPr>
+        </p:nvSpPr>
+        <p:spPr>
+          <a:xfrm>
+            <a:off x="457200" y="4832604"/>
+            <a:ext cx="365760" cy="182880"/>
+          </a:xfrm>
+          <a:prstGeom prst="rect">
+            <a:avLst/>
+          </a:prstGeom>
+          <a:extLst>
+            <a:ext uri="{C572A759-6A51-4108-AA02-DFA0A04FC94B}">
+              <ma14:wrappingTextBoxFlag xmlns:ma14="http://schemas.microsoft.com/office/mac/drawingml/2011/main" val="0"/>
+            </a:ext>
+          </a:extLst>
+        </p:spPr>
+        <p:txBody>
+          <a:bodyPr lIns="0" tIns="0" rIns="0" bIns="0"/>
+          <a:lstStyle>
+            <a:lvl1pPr>
+              <a:defRPr sz="800">
+                <a:solidFill>
+                  <a:srgbClr val="7E7E7E"/>
+                </a:solidFill>
+                <a:latin typeface="Poppins SemiBold"/>
+                <a:ea typeface="Poppins SemiBold"/>
+                <a:cs typeface="Poppins SemiBold"/>
+              </a:defRPr>
+            </a:lvl1pPr>
+          </a:lstStyle>
+          <a:p>
+            <a:pPr algn="l"/>
+            <a:fld id="{F7021451-1387-4CA6-816F-3879F97B5CBC}" type="slidenum">
+              <a:rPr b="0" lang="en-US"/>
+              <a:t>1002</a:t>
+            </a:fld>
+            <a:endParaRPr lang="en-US"/>
+          </a:p>
+        </p:txBody>
+      </p:sp>
+    </p:spTree>
+  </p:cSld>
+  <p:clrMapOvr>
+    <a:masterClrMapping/>
+  </p:clrMapOvr>
+</p:sldLayout>
+</file>
+
+<file path=ppt/slideLayouts/slideLayout3.xml><?xml version="1.0" encoding="utf-8"?>
+<p:sldLayout xmlns:a="http://schemas.openxmlformats.org/drawingml/2006/main" xmlns:r="http://schemas.openxmlformats.org/officeDocument/2006/relationships" xmlns:p="http://schemas.openxmlformats.org/presentationml/2006/main" preserve="1">
+  <p:cSld name="SABIO_COVER">
+    <p:bg>
+      <p:bgPr>
+        <a:solidFill>
+          <a:srgbClr val="1A1A1A"/>
+        </a:solidFill>
+      </p:bgPr>
+    </p:bg>
+    <p:spTree>
+      <p:nvGrpSpPr>
+        <p:cNvPr id="1" name=""/>
+        <p:cNvGrpSpPr/>
+        <p:nvPr/>
+      </p:nvGrpSpPr>
+      <p:grpSpPr>
+        <a:xfrm>
+          <a:off x="0" y="0"/>
+          <a:ext cx="0" cy="0"/>
+          <a:chOff x="0" y="0"/>
+          <a:chExt cx="0" cy="0"/>
+        </a:xfrm>
+      </p:grpSpPr>
+      <p:sp>
+        <p:nvSpPr>
+          <p:cNvPr id="2" name="Text 0"/>
+          <p:cNvSpPr/>
+          <p:nvPr/>
+        </p:nvSpPr>
+        <p:spPr>
+          <a:xfrm>
+            <a:off x="457200" y="4832604"/>
+            <a:ext cx="5852160" cy="182880"/>
+          </a:xfrm>
+          <a:prstGeom prst="rect">
+            <a:avLst/>
+          </a:prstGeom>
+          <a:noFill/>
+          <a:ln/>
+        </p:spPr>
+        <p:txBody>
+          <a:bodyPr wrap="square" lIns="0" tIns="0" rIns="0" bIns="0" rtlCol="0" anchor="t"/>
+          <a:lstStyle/>
+          <a:p>
+            <a:pPr indent="0" marL="0">
+              <a:buNone/>
+            </a:pPr>
+            <a:r>
+              <a:rPr lang="en-US" sz="700" dirty="0">
+                <a:solidFill>
+                  <a:srgbClr val="7E7E7E"/>
+                </a:solidFill>
+                <a:latin typeface="Poppins" pitchFamily="34" charset="0"/>
+                <a:ea typeface="Poppins" pitchFamily="34" charset="-122"/>
+                <a:cs typeface="Poppins" pitchFamily="34" charset="-120"/>
+              </a:rPr>
+              <a:t>Sabio Holdings · TSXV: SBIO | OTCQB: SABOF    Creator TV® | App Science® | Sabio</a:t>
+            </a:r>
+            <a:endParaRPr lang="en-US" sz="700" dirty="0"/>
+          </a:p>
+        </p:txBody>
+      </p:sp>
+    </p:spTree>
+  </p:cSld>
+  <p:clrMapOvr>
+    <a:masterClrMapping/>
+  </p:clrMapOvr>
+</p:sldLayout>
+</file>
+
 <file path=ppt/slideMasters/slideMaster1.xml><?xml version="1.0" encoding="utf-8"?>
 <p:sldMaster xmlns:a="http://schemas.openxmlformats.org/drawingml/2006/main" xmlns:r="http://schemas.openxmlformats.org/officeDocument/2006/relationships" xmlns:p="http://schemas.openxmlformats.org/presentationml/2006/main">
   <p:cSld>
@@ -1392,11 +1606,61 @@
           <a:chExt cx="0" cy="0"/>
         </a:xfrm>
       </p:grpSpPr>
+      <p:sp>
+        <p:nvSpPr>
+          <p:cNvPr id="25" name="Slide Number Placeholder 0"/>
+          <p:cNvSpPr>
+            <a:spLocks noGrp="1"/>
+          </p:cNvSpPr>
+          <p:nvPr>
+            <p:ph type="sldNum" sz="quarter" idx="4294967295"/>
+          </p:nvPr>
+        </p:nvSpPr>
+        <p:spPr>
+          <a:xfrm>
+            <a:off x="457200" y="4832604"/>
+            <a:ext cx="365760" cy="182880"/>
+          </a:xfrm>
+          <a:prstGeom prst="rect">
+            <a:avLst/>
+          </a:prstGeom>
+          <a:extLst>
+            <a:ext uri="{C572A759-6A51-4108-AA02-DFA0A04FC94B}">
+              <ma14:wrappingTextBoxFlag xmlns:ma14="http://schemas.microsoft.com/office/mac/drawingml/2011/main" val="0"/>
+            </a:ext>
+          </a:extLst>
+        </p:spPr>
+        <p:txBody>
+          <a:bodyPr lIns="0" tIns="0" rIns="0" bIns="0"/>
+          <a:lstStyle>
+            <a:lvl1pPr>
+              <a:defRPr sz="800">
+                <a:solidFill>
+                  <a:srgbClr val="7E7E7E"/>
+                </a:solidFill>
+                <a:latin typeface="Poppins SemiBold"/>
+                <a:ea typeface="Poppins SemiBold"/>
+                <a:cs typeface="Poppins SemiBold"/>
+              </a:defRPr>
+            </a:lvl1pPr>
+          </a:lstStyle>
+          <a:p>
+            <a:pPr algn="l"/>
+            <a:fld id="{F7021451-1387-4CA6-816F-3879F97B5CBC}" type="slidenum">
+              <a:rPr b="0" lang="en-US"/>
+              <a:t>null</a:t>
+            </a:fld>
+            <a:endParaRPr lang="en-US"/>
+          </a:p>
+        </p:txBody>
+      </p:sp>
     </p:spTree>
   </p:cSld>
   <p:clrMap bg1="lt1" tx1="dk1" bg2="lt2" tx2="dk2" accent1="accent1" accent2="accent2" accent3="accent3" accent4="accent4" accent5="accent5" accent6="accent6" hlink="hlink" folHlink="folHlink"/>
   <p:sldLayoutIdLst>
     <p:sldLayoutId id="2147483649" r:id="rId1"/>
+    <p:sldLayoutId id="2147483650" r:id="rId2"/>
+    <p:sldLayoutId id="2147483651" r:id="rId3"/>
   </p:sldLayoutIdLst>
   <p:hf sldNum="0" hdr="0" ftr="0" dt="0"/>
   <p:txStyles>
@@ -1655,13 +1919,6 @@
 <file path=ppt/slides/slide1.xml><?xml version="1.0" encoding="utf-8"?>
 <p:sld xmlns:a="http://schemas.openxmlformats.org/drawingml/2006/main" xmlns:r="http://schemas.openxmlformats.org/officeDocument/2006/relationships" xmlns:p="http://schemas.openxmlformats.org/presentationml/2006/main">
   <p:cSld name="Slide 1">
-    <p:bg>
-      <p:bgPr>
-        <a:solidFill>
-          <a:srgbClr val="1A1A1A"/>
-        </a:solidFill>
-      </p:bgPr>
-    </p:bg>
     <p:spTree>
       <p:nvGrpSpPr>
         <p:cNvPr id="1" name=""/>
@@ -1678,7 +1935,7 @@
       </p:grpSpPr>
       <p:pic>
         <p:nvPicPr>
-          <p:cNvPr id="2" name="Image 0" descr="/home/claude/benjaminbring-cloud/sabio-deck-builders-/assets/sabio-logo-yellow.png">    </p:cNvPr>
+          <p:cNvPr id="2" name="Image 0" descr="/home/claude/sabio-deck-builders-/assets/sabio-logo-yellow.png">    </p:cNvPr>
           <p:cNvPicPr>
             <a:picLocks noChangeAspect="1"/>
           </p:cNvPicPr>
@@ -2093,45 +2350,6 @@
               <a:t>DICK'S banner comps grew 4.9% in Q2. Foot Locker fell 3.6%, and its full-year comp guide moved to -2%. Holiday is the first big test of the combined business. [1]</a:t>
             </a:r>
             <a:endParaRPr lang="en-US" sz="900" dirty="0"/>
-          </a:p>
-        </p:txBody>
-      </p:sp>
-      <p:sp>
-        <p:nvSpPr>
-          <p:cNvPr id="13" name="Text 10"/>
-          <p:cNvSpPr txBox="1"/>
-          <p:nvPr/>
-        </p:nvSpPr>
-        <p:spPr>
-          <a:xfrm>
-            <a:off x="457200" y="4832604"/>
-            <a:ext cx="5852160" cy="182880"/>
-          </a:xfrm>
-          <a:prstGeom prst="rect">
-            <a:avLst/>
-          </a:prstGeom>
-          <a:noFill/>
-          <a:ln/>
-        </p:spPr>
-        <p:txBody>
-          <a:bodyPr wrap="square" lIns="0" tIns="0" rIns="0" bIns="0" rtlCol="0" anchor="t"/>
-          <a:lstStyle/>
-          <a:p>
-            <a:pPr indent="0" marL="0">
-              <a:buNone/>
-            </a:pPr>
-            <a:r>
-              <a:rPr lang="en-US" sz="700" dirty="0">
-                <a:solidFill>
-                  <a:srgbClr val="7E7E7E"/>
-                </a:solidFill>
-                <a:latin typeface="Poppins" pitchFamily="34" charset="0"/>
-                <a:ea typeface="Poppins" pitchFamily="34" charset="-122"/>
-                <a:cs typeface="Poppins" pitchFamily="34" charset="-120"/>
-              </a:rPr>
-              <a:t>Sabio Holdings · TSXV: SBIO | OTCQB: SABOF    Creator TV® | App Science® | Sabio</a:t>
-            </a:r>
-            <a:endParaRPr lang="en-US" sz="700" dirty="0"/>
           </a:p>
         </p:txBody>
       </p:sp>
@@ -2146,13 +2364,6 @@
 <file path=ppt/slides/slide10.xml><?xml version="1.0" encoding="utf-8"?>
 <p:sld xmlns:a="http://schemas.openxmlformats.org/drawingml/2006/main" xmlns:r="http://schemas.openxmlformats.org/officeDocument/2006/relationships" xmlns:p="http://schemas.openxmlformats.org/presentationml/2006/main">
   <p:cSld name="Slide 10">
-    <p:bg>
-      <p:bgPr>
-        <a:solidFill>
-          <a:srgbClr val="1A1A1A"/>
-        </a:solidFill>
-      </p:bgPr>
-    </p:bg>
     <p:spTree>
       <p:nvGrpSpPr>
         <p:cNvPr id="1" name=""/>
@@ -2253,120 +2464,38 @@
         </p:nvSpPr>
         <p:spPr>
           <a:xfrm>
-            <a:off x="457200" y="4832604"/>
-            <a:ext cx="365760" cy="182880"/>
-          </a:xfrm>
-          <a:prstGeom prst="rect">
-            <a:avLst/>
-          </a:prstGeom>
-          <a:noFill/>
-          <a:ln/>
-        </p:spPr>
-        <p:txBody>
-          <a:bodyPr wrap="square" lIns="0" tIns="0" rIns="0" bIns="0" rtlCol="0" anchor="t"/>
-          <a:lstStyle/>
-          <a:p>
-            <a:pPr indent="0" marL="0">
-              <a:buNone/>
-            </a:pPr>
-            <a:r>
-              <a:rPr lang="en-US" sz="800" dirty="0">
-                <a:solidFill>
-                  <a:srgbClr val="7E7E7E"/>
-                </a:solidFill>
-                <a:latin typeface="Poppins SemiBold" pitchFamily="34" charset="0"/>
-                <a:ea typeface="Poppins SemiBold" pitchFamily="34" charset="-122"/>
-                <a:cs typeface="Poppins SemiBold" pitchFamily="34" charset="-120"/>
-              </a:rPr>
-              <a:t>10</a:t>
-            </a:r>
-            <a:endParaRPr lang="en-US" sz="800" dirty="0"/>
-          </a:p>
-        </p:txBody>
-      </p:sp>
-      <p:sp>
-        <p:nvSpPr>
-          <p:cNvPr id="5" name="Text 3"/>
-          <p:cNvSpPr txBox="1"/>
-          <p:nvPr/>
-        </p:nvSpPr>
-        <p:spPr>
-          <a:xfrm>
-            <a:off x="868680" y="4832604"/>
-            <a:ext cx="5486400" cy="182880"/>
-          </a:xfrm>
-          <a:prstGeom prst="rect">
-            <a:avLst/>
-          </a:prstGeom>
-          <a:noFill/>
-          <a:ln/>
-        </p:spPr>
-        <p:txBody>
-          <a:bodyPr wrap="square" lIns="0" tIns="0" rIns="0" bIns="0" rtlCol="0" anchor="t"/>
-          <a:lstStyle/>
-          <a:p>
-            <a:pPr indent="0" marL="0">
-              <a:buNone/>
-            </a:pPr>
-            <a:r>
-              <a:rPr lang="en-US" sz="700" dirty="0">
-                <a:solidFill>
-                  <a:srgbClr val="7E7E7E"/>
+            <a:off x="457200" y="1188720"/>
+            <a:ext cx="4023360" cy="3200400"/>
+          </a:xfrm>
+          <a:prstGeom prst="rect">
+            <a:avLst/>
+          </a:prstGeom>
+          <a:noFill/>
+          <a:ln/>
+        </p:spPr>
+        <p:txBody>
+          <a:bodyPr wrap="square" lIns="0" tIns="0" rIns="0" bIns="0" rtlCol="0" anchor="t"/>
+          <a:lstStyle/>
+          <a:p>
+            <a:pPr indent="0" marL="0">
+              <a:spcAft>
+                <a:spcPts val="800"/>
+              </a:spcAft>
+              <a:buNone/>
+            </a:pPr>
+            <a:r>
+              <a:rPr lang="en-US" sz="850" dirty="0">
+                <a:solidFill>
+                  <a:srgbClr val="E3E3E3"/>
                 </a:solidFill>
                 <a:latin typeface="Poppins" pitchFamily="34" charset="0"/>
                 <a:ea typeface="Poppins" pitchFamily="34" charset="-122"/>
                 <a:cs typeface="Poppins" pitchFamily="34" charset="-120"/>
               </a:rPr>
-              <a:t>Sabio × DICK'S  ·  Proactive point of view for Zenith  ·  Confidential</a:t>
-            </a:r>
-            <a:endParaRPr lang="en-US" sz="700" dirty="0"/>
-          </a:p>
-        </p:txBody>
-      </p:sp>
-      <p:pic>
-        <p:nvPicPr>
-          <p:cNvPr id="6" name="Image 0" descr="/home/claude/benjaminbring-cloud/sabio-deck-builders-/assets/sabio-logo-white-sm.png">    </p:cNvPr>
-          <p:cNvPicPr>
-            <a:picLocks noChangeAspect="1"/>
-          </p:cNvPicPr>
-          <p:nvPr/>
-        </p:nvPicPr>
-        <p:blipFill>
-          <a:blip r:embed="rId1"/>
-          <a:stretch>
-            <a:fillRect/>
-          </a:stretch>
-        </p:blipFill>
-        <p:spPr>
-          <a:xfrm>
-            <a:off x="8028432" y="4805172"/>
-            <a:ext cx="647572" cy="155448"/>
-          </a:xfrm>
-          <a:prstGeom prst="rect">
-            <a:avLst/>
-          </a:prstGeom>
-        </p:spPr>
-      </p:pic>
-      <p:sp>
-        <p:nvSpPr>
-          <p:cNvPr id="7" name="Text 4"/>
-          <p:cNvSpPr txBox="1"/>
-          <p:nvPr/>
-        </p:nvSpPr>
-        <p:spPr>
-          <a:xfrm>
-            <a:off x="457200" y="1188720"/>
-            <a:ext cx="4023360" cy="3200400"/>
-          </a:xfrm>
-          <a:prstGeom prst="rect">
-            <a:avLst/>
-          </a:prstGeom>
-          <a:noFill/>
-          <a:ln/>
-        </p:spPr>
-        <p:txBody>
-          <a:bodyPr wrap="square" lIns="0" tIns="0" rIns="0" bIns="0" rtlCol="0" anchor="t"/>
-          <a:lstStyle/>
+              <a:t>1.  DICK'S Sporting Goods Q2 FY2026 results, Aug 25, 2026, via FashionUnited.</a:t>
+            </a:r>
+            <a:endParaRPr lang="en-US" sz="850" dirty="0"/>
+          </a:p>
           <a:p>
             <a:pPr indent="0" marL="0">
               <a:spcAft>
@@ -2383,7 +2512,7 @@
                 <a:ea typeface="Poppins" pitchFamily="34" charset="-122"/>
                 <a:cs typeface="Poppins" pitchFamily="34" charset="-120"/>
               </a:rPr>
-              <a:t>1.  DICK'S Sporting Goods Q2 FY2026 results, Aug 25, 2026, via FashionUnited.</a:t>
+              <a:t>2.  EMARKETER, Dick's experiential store strategy drives 6% comp growth, May 27, 2026.</a:t>
             </a:r>
             <a:endParaRPr lang="en-US" sz="850" dirty="0"/>
           </a:p>
@@ -2403,10 +2532,32 @@
                 <a:ea typeface="Poppins" pitchFamily="34" charset="-122"/>
                 <a:cs typeface="Poppins" pitchFamily="34" charset="-120"/>
               </a:rPr>
-              <a:t>2.  EMARKETER, Dick's experiential store strategy drives 6% comp growth, May 27, 2026.</a:t>
+              <a:t>3.  Deloitte 2026 holiday retail forecast, via Chain Store Age, Sep 10, 2026.</a:t>
             </a:r>
             <a:endParaRPr lang="en-US" sz="850" dirty="0"/>
           </a:p>
+        </p:txBody>
+      </p:sp>
+      <p:sp>
+        <p:nvSpPr>
+          <p:cNvPr id="5" name="Text 3"/>
+          <p:cNvSpPr txBox="1"/>
+          <p:nvPr/>
+        </p:nvSpPr>
+        <p:spPr>
+          <a:xfrm>
+            <a:off x="4663440" y="1188720"/>
+            <a:ext cx="4023360" cy="3200400"/>
+          </a:xfrm>
+          <a:prstGeom prst="rect">
+            <a:avLst/>
+          </a:prstGeom>
+          <a:noFill/>
+          <a:ln/>
+        </p:spPr>
+        <p:txBody>
+          <a:bodyPr wrap="square" lIns="0" tIns="0" rIns="0" bIns="0" rtlCol="0" anchor="t"/>
+          <a:lstStyle/>
           <a:p>
             <a:pPr indent="0" marL="0">
               <a:spcAft>
@@ -2423,32 +2574,10 @@
                 <a:ea typeface="Poppins" pitchFamily="34" charset="-122"/>
                 <a:cs typeface="Poppins" pitchFamily="34" charset="-120"/>
               </a:rPr>
-              <a:t>3.  Deloitte 2026 holiday retail forecast, via Chain Store Age, Sep 10, 2026.</a:t>
+              <a:t>4.  Nielsen, The Gauge, July 2026 (released Sep 10, 2026).</a:t>
             </a:r>
             <a:endParaRPr lang="en-US" sz="850" dirty="0"/>
           </a:p>
-        </p:txBody>
-      </p:sp>
-      <p:sp>
-        <p:nvSpPr>
-          <p:cNvPr id="8" name="Text 5"/>
-          <p:cNvSpPr txBox="1"/>
-          <p:nvPr/>
-        </p:nvSpPr>
-        <p:spPr>
-          <a:xfrm>
-            <a:off x="4663440" y="1188720"/>
-            <a:ext cx="4023360" cy="3200400"/>
-          </a:xfrm>
-          <a:prstGeom prst="rect">
-            <a:avLst/>
-          </a:prstGeom>
-          <a:noFill/>
-          <a:ln/>
-        </p:spPr>
-        <p:txBody>
-          <a:bodyPr wrap="square" lIns="0" tIns="0" rIns="0" bIns="0" rtlCol="0" anchor="t"/>
-          <a:lstStyle/>
           <a:p>
             <a:pPr indent="0" marL="0">
               <a:spcAft>
@@ -2465,29 +2594,57 @@
                 <a:ea typeface="Poppins" pitchFamily="34" charset="-122"/>
                 <a:cs typeface="Poppins" pitchFamily="34" charset="-120"/>
               </a:rPr>
-              <a:t>4.  Nielsen, The Gauge, July 2026 (released Sep 10, 2026).</a:t>
+              <a:t>5.  Sabio 2026 Master Case Study Deck; Sabio competitive audience pull for Zenith, Mar 2026.</a:t>
             </a:r>
             <a:endParaRPr lang="en-US" sz="850" dirty="0"/>
           </a:p>
-          <a:p>
-            <a:pPr indent="0" marL="0">
-              <a:spcAft>
-                <a:spcPts val="800"/>
-              </a:spcAft>
-              <a:buNone/>
-            </a:pPr>
-            <a:r>
-              <a:rPr lang="en-US" sz="850" dirty="0">
-                <a:solidFill>
-                  <a:srgbClr val="E3E3E3"/>
-                </a:solidFill>
-                <a:latin typeface="Poppins" pitchFamily="34" charset="0"/>
-                <a:ea typeface="Poppins" pitchFamily="34" charset="-122"/>
-                <a:cs typeface="Poppins" pitchFamily="34" charset="-120"/>
-              </a:rPr>
-              <a:t>5.  Sabio 2026 Master Case Study Deck; Sabio competitive audience pull for Zenith, Mar 2026.</a:t>
-            </a:r>
-            <a:endParaRPr lang="en-US" sz="850" dirty="0"/>
+        </p:txBody>
+      </p:sp>
+      <p:sp>
+        <p:nvSpPr>
+          <p:cNvPr id="25" name="Slide Number Placeholder 0"/>
+          <p:cNvSpPr>
+            <a:spLocks noGrp="1"/>
+          </p:cNvSpPr>
+          <p:nvPr>
+            <p:ph type="sldNum" sz="quarter" idx="4294967295"/>
+          </p:nvPr>
+        </p:nvSpPr>
+        <p:spPr>
+          <a:xfrm>
+            <a:off x="457200" y="4832604"/>
+            <a:ext cx="365760" cy="182880"/>
+          </a:xfrm>
+          <a:prstGeom prst="rect">
+            <a:avLst/>
+          </a:prstGeom>
+          <a:extLst>
+            <a:ext uri="{C572A759-6A51-4108-AA02-DFA0A04FC94B}">
+              <ma14:wrappingTextBoxFlag xmlns:ma14="http://schemas.microsoft.com/office/mac/drawingml/2011/main" val="0"/>
+            </a:ext>
+          </a:extLst>
+        </p:spPr>
+        <p:txBody>
+          <a:bodyPr lIns="0" tIns="0" rIns="0" bIns="0"/>
+          <a:lstStyle>
+            <a:lvl1pPr>
+              <a:defRPr sz="800">
+                <a:solidFill>
+                  <a:srgbClr val="7E7E7E"/>
+                </a:solidFill>
+                <a:latin typeface="Poppins SemiBold"/>
+                <a:ea typeface="Poppins SemiBold"/>
+                <a:cs typeface="Poppins SemiBold"/>
+              </a:defRPr>
+            </a:lvl1pPr>
+          </a:lstStyle>
+          <a:p>
+            <a:pPr algn="l"/>
+            <a:fld id="{F7021451-1387-4CA6-816F-3879F97B5CBC}" type="slidenum">
+              <a:rPr b="0" lang="en-US"/>
+              <a:t>10</a:t>
+            </a:fld>
+            <a:endParaRPr lang="en-US"/>
           </a:p>
         </p:txBody>
       </p:sp>
@@ -2502,13 +2659,6 @@
 <file path=ppt/slides/slide2.xml><?xml version="1.0" encoding="utf-8"?>
 <p:sld xmlns:a="http://schemas.openxmlformats.org/drawingml/2006/main" xmlns:r="http://schemas.openxmlformats.org/officeDocument/2006/relationships" xmlns:p="http://schemas.openxmlformats.org/presentationml/2006/main">
   <p:cSld name="Slide 2">
-    <p:bg>
-      <p:bgPr>
-        <a:solidFill>
-          <a:srgbClr val="1A1A1A"/>
-        </a:solidFill>
-      </p:bgPr>
-    </p:bg>
     <p:spTree>
       <p:nvGrpSpPr>
         <p:cNvPr id="1" name=""/>
@@ -2603,109 +2753,7 @@
       </p:sp>
       <p:sp>
         <p:nvSpPr>
-          <p:cNvPr id="4" name="Text 2"/>
-          <p:cNvSpPr txBox="1"/>
-          <p:nvPr/>
-        </p:nvSpPr>
-        <p:spPr>
-          <a:xfrm>
-            <a:off x="457200" y="4832604"/>
-            <a:ext cx="365760" cy="182880"/>
-          </a:xfrm>
-          <a:prstGeom prst="rect">
-            <a:avLst/>
-          </a:prstGeom>
-          <a:noFill/>
-          <a:ln/>
-        </p:spPr>
-        <p:txBody>
-          <a:bodyPr wrap="square" lIns="0" tIns="0" rIns="0" bIns="0" rtlCol="0" anchor="t"/>
-          <a:lstStyle/>
-          <a:p>
-            <a:pPr indent="0" marL="0">
-              <a:buNone/>
-            </a:pPr>
-            <a:r>
-              <a:rPr lang="en-US" sz="800" dirty="0">
-                <a:solidFill>
-                  <a:srgbClr val="7E7E7E"/>
-                </a:solidFill>
-                <a:latin typeface="Poppins SemiBold" pitchFamily="34" charset="0"/>
-                <a:ea typeface="Poppins SemiBold" pitchFamily="34" charset="-122"/>
-                <a:cs typeface="Poppins SemiBold" pitchFamily="34" charset="-120"/>
-              </a:rPr>
-              <a:t>2</a:t>
-            </a:r>
-            <a:endParaRPr lang="en-US" sz="800" dirty="0"/>
-          </a:p>
-        </p:txBody>
-      </p:sp>
-      <p:sp>
-        <p:nvSpPr>
-          <p:cNvPr id="5" name="Text 3"/>
-          <p:cNvSpPr txBox="1"/>
-          <p:nvPr/>
-        </p:nvSpPr>
-        <p:spPr>
-          <a:xfrm>
-            <a:off x="868680" y="4832604"/>
-            <a:ext cx="5486400" cy="182880"/>
-          </a:xfrm>
-          <a:prstGeom prst="rect">
-            <a:avLst/>
-          </a:prstGeom>
-          <a:noFill/>
-          <a:ln/>
-        </p:spPr>
-        <p:txBody>
-          <a:bodyPr wrap="square" lIns="0" tIns="0" rIns="0" bIns="0" rtlCol="0" anchor="t"/>
-          <a:lstStyle/>
-          <a:p>
-            <a:pPr indent="0" marL="0">
-              <a:buNone/>
-            </a:pPr>
-            <a:r>
-              <a:rPr lang="en-US" sz="700" dirty="0">
-                <a:solidFill>
-                  <a:srgbClr val="7E7E7E"/>
-                </a:solidFill>
-                <a:latin typeface="Poppins" pitchFamily="34" charset="0"/>
-                <a:ea typeface="Poppins" pitchFamily="34" charset="-122"/>
-                <a:cs typeface="Poppins" pitchFamily="34" charset="-120"/>
-              </a:rPr>
-              <a:t>Sabio × DICK'S  ·  Proactive point of view for Zenith  ·  Confidential</a:t>
-            </a:r>
-            <a:endParaRPr lang="en-US" sz="700" dirty="0"/>
-          </a:p>
-        </p:txBody>
-      </p:sp>
-      <p:pic>
-        <p:nvPicPr>
-          <p:cNvPr id="6" name="Image 0" descr="/home/claude/benjaminbring-cloud/sabio-deck-builders-/assets/sabio-logo-white-sm.png">    </p:cNvPr>
-          <p:cNvPicPr>
-            <a:picLocks noChangeAspect="1"/>
-          </p:cNvPicPr>
-          <p:nvPr/>
-        </p:nvPicPr>
-        <p:blipFill>
-          <a:blip r:embed="rId1"/>
-          <a:stretch>
-            <a:fillRect/>
-          </a:stretch>
-        </p:blipFill>
-        <p:spPr>
-          <a:xfrm>
-            <a:off x="8028432" y="4805172"/>
-            <a:ext cx="647572" cy="155448"/>
-          </a:xfrm>
-          <a:prstGeom prst="rect">
-            <a:avLst/>
-          </a:prstGeom>
-        </p:spPr>
-      </p:pic>
-      <p:sp>
-        <p:nvSpPr>
-          <p:cNvPr id="7" name="Shape 4"/>
+          <p:cNvPr id="4" name="Shape 2"/>
           <p:cNvSpPr/>
           <p:nvPr/>
         </p:nvSpPr>
@@ -2730,7 +2778,7 @@
       </p:sp>
       <p:sp>
         <p:nvSpPr>
-          <p:cNvPr id="8" name="Text 5"/>
+          <p:cNvPr id="5" name="Text 3"/>
           <p:cNvSpPr txBox="1"/>
           <p:nvPr/>
         </p:nvSpPr>
@@ -2769,7 +2817,7 @@
       </p:sp>
       <p:sp>
         <p:nvSpPr>
-          <p:cNvPr id="9" name="Text 6"/>
+          <p:cNvPr id="6" name="Text 4"/>
           <p:cNvSpPr txBox="1"/>
           <p:nvPr/>
         </p:nvSpPr>
@@ -2808,7 +2856,7 @@
       </p:sp>
       <p:sp>
         <p:nvSpPr>
-          <p:cNvPr id="10" name="Text 7"/>
+          <p:cNvPr id="7" name="Text 5"/>
           <p:cNvSpPr txBox="1"/>
           <p:nvPr/>
         </p:nvSpPr>
@@ -2847,7 +2895,7 @@
       </p:sp>
       <p:sp>
         <p:nvSpPr>
-          <p:cNvPr id="11" name="Shape 8"/>
+          <p:cNvPr id="8" name="Shape 6"/>
           <p:cNvSpPr/>
           <p:nvPr/>
         </p:nvSpPr>
@@ -2872,7 +2920,7 @@
       </p:sp>
       <p:sp>
         <p:nvSpPr>
-          <p:cNvPr id="12" name="Text 9"/>
+          <p:cNvPr id="9" name="Text 7"/>
           <p:cNvSpPr txBox="1"/>
           <p:nvPr/>
         </p:nvSpPr>
@@ -2911,7 +2959,7 @@
       </p:sp>
       <p:sp>
         <p:nvSpPr>
-          <p:cNvPr id="13" name="Text 10"/>
+          <p:cNvPr id="10" name="Text 8"/>
           <p:cNvSpPr txBox="1"/>
           <p:nvPr/>
         </p:nvSpPr>
@@ -2950,7 +2998,7 @@
       </p:sp>
       <p:sp>
         <p:nvSpPr>
-          <p:cNvPr id="14" name="Shape 11"/>
+          <p:cNvPr id="11" name="Shape 9"/>
           <p:cNvSpPr/>
           <p:nvPr/>
         </p:nvSpPr>
@@ -2975,7 +3023,7 @@
       </p:sp>
       <p:sp>
         <p:nvSpPr>
-          <p:cNvPr id="15" name="Text 12"/>
+          <p:cNvPr id="12" name="Text 10"/>
           <p:cNvSpPr txBox="1"/>
           <p:nvPr/>
         </p:nvSpPr>
@@ -3014,7 +3062,7 @@
       </p:sp>
       <p:sp>
         <p:nvSpPr>
-          <p:cNvPr id="16" name="Text 13"/>
+          <p:cNvPr id="13" name="Text 11"/>
           <p:cNvSpPr txBox="1"/>
           <p:nvPr/>
         </p:nvSpPr>
@@ -3053,7 +3101,7 @@
       </p:sp>
       <p:sp>
         <p:nvSpPr>
-          <p:cNvPr id="17" name="Text 14"/>
+          <p:cNvPr id="14" name="Text 12"/>
           <p:cNvSpPr txBox="1"/>
           <p:nvPr/>
         </p:nvSpPr>
@@ -3092,7 +3140,7 @@
       </p:sp>
       <p:sp>
         <p:nvSpPr>
-          <p:cNvPr id="18" name="Shape 15"/>
+          <p:cNvPr id="15" name="Shape 13"/>
           <p:cNvSpPr/>
           <p:nvPr/>
         </p:nvSpPr>
@@ -3117,7 +3165,7 @@
       </p:sp>
       <p:sp>
         <p:nvSpPr>
-          <p:cNvPr id="19" name="Text 16"/>
+          <p:cNvPr id="16" name="Text 14"/>
           <p:cNvSpPr txBox="1"/>
           <p:nvPr/>
         </p:nvSpPr>
@@ -3156,7 +3204,7 @@
       </p:sp>
       <p:sp>
         <p:nvSpPr>
-          <p:cNvPr id="20" name="Text 17"/>
+          <p:cNvPr id="17" name="Text 15"/>
           <p:cNvSpPr txBox="1"/>
           <p:nvPr/>
         </p:nvSpPr>
@@ -3195,7 +3243,7 @@
       </p:sp>
       <p:sp>
         <p:nvSpPr>
-          <p:cNvPr id="21" name="Shape 18"/>
+          <p:cNvPr id="18" name="Shape 16"/>
           <p:cNvSpPr/>
           <p:nvPr/>
         </p:nvSpPr>
@@ -3220,7 +3268,7 @@
       </p:sp>
       <p:sp>
         <p:nvSpPr>
-          <p:cNvPr id="22" name="Text 19"/>
+          <p:cNvPr id="19" name="Text 17"/>
           <p:cNvSpPr txBox="1"/>
           <p:nvPr/>
         </p:nvSpPr>
@@ -3259,7 +3307,7 @@
       </p:sp>
       <p:sp>
         <p:nvSpPr>
-          <p:cNvPr id="23" name="Text 20"/>
+          <p:cNvPr id="20" name="Text 18"/>
           <p:cNvSpPr txBox="1"/>
           <p:nvPr/>
         </p:nvSpPr>
@@ -3298,7 +3346,7 @@
       </p:sp>
       <p:sp>
         <p:nvSpPr>
-          <p:cNvPr id="24" name="Text 21"/>
+          <p:cNvPr id="21" name="Text 19"/>
           <p:cNvSpPr txBox="1"/>
           <p:nvPr/>
         </p:nvSpPr>
@@ -3337,7 +3385,7 @@
       </p:sp>
       <p:sp>
         <p:nvSpPr>
-          <p:cNvPr id="25" name="Shape 22"/>
+          <p:cNvPr id="22" name="Shape 20"/>
           <p:cNvSpPr/>
           <p:nvPr/>
         </p:nvSpPr>
@@ -3362,7 +3410,7 @@
       </p:sp>
       <p:sp>
         <p:nvSpPr>
-          <p:cNvPr id="26" name="Text 23"/>
+          <p:cNvPr id="23" name="Text 21"/>
           <p:cNvSpPr txBox="1"/>
           <p:nvPr/>
         </p:nvSpPr>
@@ -3401,7 +3449,7 @@
       </p:sp>
       <p:sp>
         <p:nvSpPr>
-          <p:cNvPr id="27" name="Text 24"/>
+          <p:cNvPr id="24" name="Text 22"/>
           <p:cNvSpPr txBox="1"/>
           <p:nvPr/>
         </p:nvSpPr>
@@ -3440,7 +3488,7 @@
       </p:sp>
       <p:sp>
         <p:nvSpPr>
-          <p:cNvPr id="28" name="Shape 25"/>
+          <p:cNvPr id="25" name="Shape 23"/>
           <p:cNvSpPr/>
           <p:nvPr/>
         </p:nvSpPr>
@@ -3465,7 +3513,7 @@
       </p:sp>
       <p:sp>
         <p:nvSpPr>
-          <p:cNvPr id="29" name="Text 26"/>
+          <p:cNvPr id="26" name="Text 24"/>
           <p:cNvSpPr txBox="1"/>
           <p:nvPr/>
         </p:nvSpPr>
@@ -3504,7 +3552,7 @@
       </p:sp>
       <p:sp>
         <p:nvSpPr>
-          <p:cNvPr id="30" name="Text 27"/>
+          <p:cNvPr id="27" name="Text 25"/>
           <p:cNvSpPr txBox="1"/>
           <p:nvPr/>
         </p:nvSpPr>
@@ -3543,7 +3591,7 @@
       </p:sp>
       <p:sp>
         <p:nvSpPr>
-          <p:cNvPr id="31" name="Text 28"/>
+          <p:cNvPr id="28" name="Text 26"/>
           <p:cNvSpPr txBox="1"/>
           <p:nvPr/>
         </p:nvSpPr>
@@ -3582,7 +3630,7 @@
       </p:sp>
       <p:sp>
         <p:nvSpPr>
-          <p:cNvPr id="32" name="Shape 29"/>
+          <p:cNvPr id="29" name="Shape 27"/>
           <p:cNvSpPr/>
           <p:nvPr/>
         </p:nvSpPr>
@@ -3607,7 +3655,7 @@
       </p:sp>
       <p:sp>
         <p:nvSpPr>
-          <p:cNvPr id="33" name="Text 30"/>
+          <p:cNvPr id="30" name="Text 28"/>
           <p:cNvSpPr txBox="1"/>
           <p:nvPr/>
         </p:nvSpPr>
@@ -3646,7 +3694,7 @@
       </p:sp>
       <p:sp>
         <p:nvSpPr>
-          <p:cNvPr id="34" name="Text 31"/>
+          <p:cNvPr id="31" name="Text 29"/>
           <p:cNvSpPr txBox="1"/>
           <p:nvPr/>
         </p:nvSpPr>
@@ -3680,6 +3728,54 @@
               <a:t>A modest season rewards share-taking, not waiting for the market.</a:t>
             </a:r>
             <a:endParaRPr lang="en-US" sz="800" dirty="0"/>
+          </a:p>
+        </p:txBody>
+      </p:sp>
+      <p:sp>
+        <p:nvSpPr>
+          <p:cNvPr id="25" name="Slide Number Placeholder 0"/>
+          <p:cNvSpPr>
+            <a:spLocks noGrp="1"/>
+          </p:cNvSpPr>
+          <p:nvPr>
+            <p:ph type="sldNum" sz="quarter" idx="4294967295"/>
+          </p:nvPr>
+        </p:nvSpPr>
+        <p:spPr>
+          <a:xfrm>
+            <a:off x="457200" y="4832604"/>
+            <a:ext cx="365760" cy="182880"/>
+          </a:xfrm>
+          <a:prstGeom prst="rect">
+            <a:avLst/>
+          </a:prstGeom>
+          <a:extLst>
+            <a:ext uri="{C572A759-6A51-4108-AA02-DFA0A04FC94B}">
+              <ma14:wrappingTextBoxFlag xmlns:ma14="http://schemas.microsoft.com/office/mac/drawingml/2011/main" val="0"/>
+            </a:ext>
+          </a:extLst>
+        </p:spPr>
+        <p:txBody>
+          <a:bodyPr lIns="0" tIns="0" rIns="0" bIns="0"/>
+          <a:lstStyle>
+            <a:lvl1pPr>
+              <a:defRPr sz="800">
+                <a:solidFill>
+                  <a:srgbClr val="7E7E7E"/>
+                </a:solidFill>
+                <a:latin typeface="Poppins SemiBold"/>
+                <a:ea typeface="Poppins SemiBold"/>
+                <a:cs typeface="Poppins SemiBold"/>
+              </a:defRPr>
+            </a:lvl1pPr>
+          </a:lstStyle>
+          <a:p>
+            <a:pPr algn="l"/>
+            <a:fld id="{F7021451-1387-4CA6-816F-3879F97B5CBC}" type="slidenum">
+              <a:rPr b="0" lang="en-US"/>
+              <a:t>2</a:t>
+            </a:fld>
+            <a:endParaRPr lang="en-US"/>
           </a:p>
         </p:txBody>
       </p:sp>
@@ -3694,13 +3790,6 @@
 <file path=ppt/slides/slide3.xml><?xml version="1.0" encoding="utf-8"?>
 <p:sld xmlns:a="http://schemas.openxmlformats.org/drawingml/2006/main" xmlns:r="http://schemas.openxmlformats.org/officeDocument/2006/relationships" xmlns:p="http://schemas.openxmlformats.org/presentationml/2006/main">
   <p:cSld name="Slide 3">
-    <p:bg>
-      <p:bgPr>
-        <a:solidFill>
-          <a:srgbClr val="1A1A1A"/>
-        </a:solidFill>
-      </p:bgPr>
-    </p:bg>
     <p:spTree>
       <p:nvGrpSpPr>
         <p:cNvPr id="1" name=""/>
@@ -3795,109 +3884,7 @@
       </p:sp>
       <p:sp>
         <p:nvSpPr>
-          <p:cNvPr id="4" name="Text 2"/>
-          <p:cNvSpPr txBox="1"/>
-          <p:nvPr/>
-        </p:nvSpPr>
-        <p:spPr>
-          <a:xfrm>
-            <a:off x="457200" y="4832604"/>
-            <a:ext cx="365760" cy="182880"/>
-          </a:xfrm>
-          <a:prstGeom prst="rect">
-            <a:avLst/>
-          </a:prstGeom>
-          <a:noFill/>
-          <a:ln/>
-        </p:spPr>
-        <p:txBody>
-          <a:bodyPr wrap="square" lIns="0" tIns="0" rIns="0" bIns="0" rtlCol="0" anchor="t"/>
-          <a:lstStyle/>
-          <a:p>
-            <a:pPr indent="0" marL="0">
-              <a:buNone/>
-            </a:pPr>
-            <a:r>
-              <a:rPr lang="en-US" sz="800" dirty="0">
-                <a:solidFill>
-                  <a:srgbClr val="7E7E7E"/>
-                </a:solidFill>
-                <a:latin typeface="Poppins SemiBold" pitchFamily="34" charset="0"/>
-                <a:ea typeface="Poppins SemiBold" pitchFamily="34" charset="-122"/>
-                <a:cs typeface="Poppins SemiBold" pitchFamily="34" charset="-120"/>
-              </a:rPr>
-              <a:t>3</a:t>
-            </a:r>
-            <a:endParaRPr lang="en-US" sz="800" dirty="0"/>
-          </a:p>
-        </p:txBody>
-      </p:sp>
-      <p:sp>
-        <p:nvSpPr>
-          <p:cNvPr id="5" name="Text 3"/>
-          <p:cNvSpPr txBox="1"/>
-          <p:nvPr/>
-        </p:nvSpPr>
-        <p:spPr>
-          <a:xfrm>
-            <a:off x="868680" y="4832604"/>
-            <a:ext cx="5486400" cy="182880"/>
-          </a:xfrm>
-          <a:prstGeom prst="rect">
-            <a:avLst/>
-          </a:prstGeom>
-          <a:noFill/>
-          <a:ln/>
-        </p:spPr>
-        <p:txBody>
-          <a:bodyPr wrap="square" lIns="0" tIns="0" rIns="0" bIns="0" rtlCol="0" anchor="t"/>
-          <a:lstStyle/>
-          <a:p>
-            <a:pPr indent="0" marL="0">
-              <a:buNone/>
-            </a:pPr>
-            <a:r>
-              <a:rPr lang="en-US" sz="700" dirty="0">
-                <a:solidFill>
-                  <a:srgbClr val="7E7E7E"/>
-                </a:solidFill>
-                <a:latin typeface="Poppins" pitchFamily="34" charset="0"/>
-                <a:ea typeface="Poppins" pitchFamily="34" charset="-122"/>
-                <a:cs typeface="Poppins" pitchFamily="34" charset="-120"/>
-              </a:rPr>
-              <a:t>Sabio × DICK'S  ·  Proactive point of view for Zenith  ·  Confidential</a:t>
-            </a:r>
-            <a:endParaRPr lang="en-US" sz="700" dirty="0"/>
-          </a:p>
-        </p:txBody>
-      </p:sp>
-      <p:pic>
-        <p:nvPicPr>
-          <p:cNvPr id="6" name="Image 0" descr="/home/claude/benjaminbring-cloud/sabio-deck-builders-/assets/sabio-logo-white-sm.png">    </p:cNvPr>
-          <p:cNvPicPr>
-            <a:picLocks noChangeAspect="1"/>
-          </p:cNvPicPr>
-          <p:nvPr/>
-        </p:nvPicPr>
-        <p:blipFill>
-          <a:blip r:embed="rId1"/>
-          <a:stretch>
-            <a:fillRect/>
-          </a:stretch>
-        </p:blipFill>
-        <p:spPr>
-          <a:xfrm>
-            <a:off x="8028432" y="4805172"/>
-            <a:ext cx="647572" cy="155448"/>
-          </a:xfrm>
-          <a:prstGeom prst="rect">
-            <a:avLst/>
-          </a:prstGeom>
-        </p:spPr>
-      </p:pic>
-      <p:sp>
-        <p:nvSpPr>
-          <p:cNvPr id="7" name="Shape 4"/>
+          <p:cNvPr id="4" name="Shape 2"/>
           <p:cNvSpPr/>
           <p:nvPr/>
         </p:nvSpPr>
@@ -3922,7 +3909,7 @@
       </p:sp>
       <p:sp>
         <p:nvSpPr>
-          <p:cNvPr id="8" name="Text 5"/>
+          <p:cNvPr id="5" name="Text 3"/>
           <p:cNvSpPr txBox="1"/>
           <p:nvPr/>
         </p:nvSpPr>
@@ -3961,7 +3948,7 @@
       </p:sp>
       <p:sp>
         <p:nvSpPr>
-          <p:cNvPr id="9" name="Text 6"/>
+          <p:cNvPr id="6" name="Text 4"/>
           <p:cNvSpPr txBox="1"/>
           <p:nvPr/>
         </p:nvSpPr>
@@ -4000,7 +3987,7 @@
       </p:sp>
       <p:sp>
         <p:nvSpPr>
-          <p:cNvPr id="10" name="Text 7"/>
+          <p:cNvPr id="7" name="Text 5"/>
           <p:cNvSpPr txBox="1"/>
           <p:nvPr/>
         </p:nvSpPr>
@@ -4039,7 +4026,7 @@
       </p:sp>
       <p:sp>
         <p:nvSpPr>
-          <p:cNvPr id="11" name="Text 8"/>
+          <p:cNvPr id="8" name="Text 6"/>
           <p:cNvSpPr txBox="1"/>
           <p:nvPr/>
         </p:nvSpPr>
@@ -4078,7 +4065,7 @@
       </p:sp>
       <p:sp>
         <p:nvSpPr>
-          <p:cNvPr id="12" name="Text 9"/>
+          <p:cNvPr id="9" name="Text 7"/>
           <p:cNvSpPr txBox="1"/>
           <p:nvPr/>
         </p:nvSpPr>
@@ -4117,7 +4104,7 @@
       </p:sp>
       <p:sp>
         <p:nvSpPr>
-          <p:cNvPr id="13" name="Text 10"/>
+          <p:cNvPr id="10" name="Text 8"/>
           <p:cNvSpPr txBox="1"/>
           <p:nvPr/>
         </p:nvSpPr>
@@ -4156,7 +4143,7 @@
       </p:sp>
       <p:sp>
         <p:nvSpPr>
-          <p:cNvPr id="14" name="Text 11"/>
+          <p:cNvPr id="11" name="Text 9"/>
           <p:cNvSpPr txBox="1"/>
           <p:nvPr/>
         </p:nvSpPr>
@@ -4195,7 +4182,7 @@
       </p:sp>
       <p:sp>
         <p:nvSpPr>
-          <p:cNvPr id="15" name="Text 12"/>
+          <p:cNvPr id="12" name="Text 10"/>
           <p:cNvSpPr txBox="1"/>
           <p:nvPr/>
         </p:nvSpPr>
@@ -4234,7 +4221,7 @@
       </p:sp>
       <p:sp>
         <p:nvSpPr>
-          <p:cNvPr id="16" name="Text 13"/>
+          <p:cNvPr id="13" name="Text 11"/>
           <p:cNvSpPr txBox="1"/>
           <p:nvPr/>
         </p:nvSpPr>
@@ -4273,7 +4260,7 @@
       </p:sp>
       <p:sp>
         <p:nvSpPr>
-          <p:cNvPr id="17" name="Text 14"/>
+          <p:cNvPr id="14" name="Text 12"/>
           <p:cNvSpPr txBox="1"/>
           <p:nvPr/>
         </p:nvSpPr>
@@ -4307,6 +4294,54 @@
               <a:t>Half of TV time is streaming. We put the plan there, then follow the same homes to the phone and the store.</a:t>
             </a:r>
             <a:endParaRPr lang="en-US" sz="950" dirty="0"/>
+          </a:p>
+        </p:txBody>
+      </p:sp>
+      <p:sp>
+        <p:nvSpPr>
+          <p:cNvPr id="25" name="Slide Number Placeholder 0"/>
+          <p:cNvSpPr>
+            <a:spLocks noGrp="1"/>
+          </p:cNvSpPr>
+          <p:nvPr>
+            <p:ph type="sldNum" sz="quarter" idx="4294967295"/>
+          </p:nvPr>
+        </p:nvSpPr>
+        <p:spPr>
+          <a:xfrm>
+            <a:off x="457200" y="4832604"/>
+            <a:ext cx="365760" cy="182880"/>
+          </a:xfrm>
+          <a:prstGeom prst="rect">
+            <a:avLst/>
+          </a:prstGeom>
+          <a:extLst>
+            <a:ext uri="{C572A759-6A51-4108-AA02-DFA0A04FC94B}">
+              <ma14:wrappingTextBoxFlag xmlns:ma14="http://schemas.microsoft.com/office/mac/drawingml/2011/main" val="0"/>
+            </a:ext>
+          </a:extLst>
+        </p:spPr>
+        <p:txBody>
+          <a:bodyPr lIns="0" tIns="0" rIns="0" bIns="0"/>
+          <a:lstStyle>
+            <a:lvl1pPr>
+              <a:defRPr sz="800">
+                <a:solidFill>
+                  <a:srgbClr val="7E7E7E"/>
+                </a:solidFill>
+                <a:latin typeface="Poppins SemiBold"/>
+                <a:ea typeface="Poppins SemiBold"/>
+                <a:cs typeface="Poppins SemiBold"/>
+              </a:defRPr>
+            </a:lvl1pPr>
+          </a:lstStyle>
+          <a:p>
+            <a:pPr algn="l"/>
+            <a:fld id="{F7021451-1387-4CA6-816F-3879F97B5CBC}" type="slidenum">
+              <a:rPr b="0" lang="en-US"/>
+              <a:t>3</a:t>
+            </a:fld>
+            <a:endParaRPr lang="en-US"/>
           </a:p>
         </p:txBody>
       </p:sp>
@@ -4321,13 +4356,6 @@
 <file path=ppt/slides/slide4.xml><?xml version="1.0" encoding="utf-8"?>
 <p:sld xmlns:a="http://schemas.openxmlformats.org/drawingml/2006/main" xmlns:r="http://schemas.openxmlformats.org/officeDocument/2006/relationships" xmlns:p="http://schemas.openxmlformats.org/presentationml/2006/main">
   <p:cSld name="Slide 4">
-    <p:bg>
-      <p:bgPr>
-        <a:solidFill>
-          <a:srgbClr val="1A1A1A"/>
-        </a:solidFill>
-      </p:bgPr>
-    </p:bg>
     <p:spTree>
       <p:nvGrpSpPr>
         <p:cNvPr id="1" name=""/>
@@ -4422,109 +4450,7 @@
       </p:sp>
       <p:sp>
         <p:nvSpPr>
-          <p:cNvPr id="4" name="Text 2"/>
-          <p:cNvSpPr txBox="1"/>
-          <p:nvPr/>
-        </p:nvSpPr>
-        <p:spPr>
-          <a:xfrm>
-            <a:off x="457200" y="4832604"/>
-            <a:ext cx="365760" cy="182880"/>
-          </a:xfrm>
-          <a:prstGeom prst="rect">
-            <a:avLst/>
-          </a:prstGeom>
-          <a:noFill/>
-          <a:ln/>
-        </p:spPr>
-        <p:txBody>
-          <a:bodyPr wrap="square" lIns="0" tIns="0" rIns="0" bIns="0" rtlCol="0" anchor="t"/>
-          <a:lstStyle/>
-          <a:p>
-            <a:pPr indent="0" marL="0">
-              <a:buNone/>
-            </a:pPr>
-            <a:r>
-              <a:rPr lang="en-US" sz="800" dirty="0">
-                <a:solidFill>
-                  <a:srgbClr val="7E7E7E"/>
-                </a:solidFill>
-                <a:latin typeface="Poppins SemiBold" pitchFamily="34" charset="0"/>
-                <a:ea typeface="Poppins SemiBold" pitchFamily="34" charset="-122"/>
-                <a:cs typeface="Poppins SemiBold" pitchFamily="34" charset="-120"/>
-              </a:rPr>
-              <a:t>4</a:t>
-            </a:r>
-            <a:endParaRPr lang="en-US" sz="800" dirty="0"/>
-          </a:p>
-        </p:txBody>
-      </p:sp>
-      <p:sp>
-        <p:nvSpPr>
-          <p:cNvPr id="5" name="Text 3"/>
-          <p:cNvSpPr txBox="1"/>
-          <p:nvPr/>
-        </p:nvSpPr>
-        <p:spPr>
-          <a:xfrm>
-            <a:off x="868680" y="4832604"/>
-            <a:ext cx="5486400" cy="182880"/>
-          </a:xfrm>
-          <a:prstGeom prst="rect">
-            <a:avLst/>
-          </a:prstGeom>
-          <a:noFill/>
-          <a:ln/>
-        </p:spPr>
-        <p:txBody>
-          <a:bodyPr wrap="square" lIns="0" tIns="0" rIns="0" bIns="0" rtlCol="0" anchor="t"/>
-          <a:lstStyle/>
-          <a:p>
-            <a:pPr indent="0" marL="0">
-              <a:buNone/>
-            </a:pPr>
-            <a:r>
-              <a:rPr lang="en-US" sz="700" dirty="0">
-                <a:solidFill>
-                  <a:srgbClr val="7E7E7E"/>
-                </a:solidFill>
-                <a:latin typeface="Poppins" pitchFamily="34" charset="0"/>
-                <a:ea typeface="Poppins" pitchFamily="34" charset="-122"/>
-                <a:cs typeface="Poppins" pitchFamily="34" charset="-120"/>
-              </a:rPr>
-              <a:t>Sabio × DICK'S  ·  Proactive point of view for Zenith  ·  Confidential</a:t>
-            </a:r>
-            <a:endParaRPr lang="en-US" sz="700" dirty="0"/>
-          </a:p>
-        </p:txBody>
-      </p:sp>
-      <p:pic>
-        <p:nvPicPr>
-          <p:cNvPr id="6" name="Image 0" descr="/home/claude/benjaminbring-cloud/sabio-deck-builders-/assets/sabio-logo-white-sm.png">    </p:cNvPr>
-          <p:cNvPicPr>
-            <a:picLocks noChangeAspect="1"/>
-          </p:cNvPicPr>
-          <p:nvPr/>
-        </p:nvPicPr>
-        <p:blipFill>
-          <a:blip r:embed="rId1"/>
-          <a:stretch>
-            <a:fillRect/>
-          </a:stretch>
-        </p:blipFill>
-        <p:spPr>
-          <a:xfrm>
-            <a:off x="8028432" y="4805172"/>
-            <a:ext cx="647572" cy="155448"/>
-          </a:xfrm>
-          <a:prstGeom prst="rect">
-            <a:avLst/>
-          </a:prstGeom>
-        </p:spPr>
-      </p:pic>
-      <p:sp>
-        <p:nvSpPr>
-          <p:cNvPr id="7" name="Shape 4"/>
+          <p:cNvPr id="4" name="Shape 2"/>
           <p:cNvSpPr/>
           <p:nvPr/>
         </p:nvSpPr>
@@ -4549,7 +4475,7 @@
       </p:sp>
       <p:sp>
         <p:nvSpPr>
-          <p:cNvPr id="8" name="Text 5"/>
+          <p:cNvPr id="5" name="Text 3"/>
           <p:cNvSpPr txBox="1"/>
           <p:nvPr/>
         </p:nvSpPr>
@@ -4588,7 +4514,7 @@
       </p:sp>
       <p:sp>
         <p:nvSpPr>
-          <p:cNvPr id="9" name="Text 6"/>
+          <p:cNvPr id="6" name="Text 4"/>
           <p:cNvSpPr txBox="1"/>
           <p:nvPr/>
         </p:nvSpPr>
@@ -4627,7 +4553,7 @@
       </p:sp>
       <p:sp>
         <p:nvSpPr>
-          <p:cNvPr id="10" name="Shape 7"/>
+          <p:cNvPr id="7" name="Shape 5"/>
           <p:cNvSpPr/>
           <p:nvPr/>
         </p:nvSpPr>
@@ -4652,7 +4578,7 @@
       </p:sp>
       <p:sp>
         <p:nvSpPr>
-          <p:cNvPr id="11" name="Text 8"/>
+          <p:cNvPr id="8" name="Text 6"/>
           <p:cNvSpPr txBox="1"/>
           <p:nvPr/>
         </p:nvSpPr>
@@ -4691,7 +4617,7 @@
       </p:sp>
       <p:sp>
         <p:nvSpPr>
-          <p:cNvPr id="12" name="Text 9"/>
+          <p:cNvPr id="9" name="Text 7"/>
           <p:cNvSpPr txBox="1"/>
           <p:nvPr/>
         </p:nvSpPr>
@@ -4730,7 +4656,7 @@
       </p:sp>
       <p:sp>
         <p:nvSpPr>
-          <p:cNvPr id="13" name="Shape 10"/>
+          <p:cNvPr id="10" name="Shape 8"/>
           <p:cNvSpPr/>
           <p:nvPr/>
         </p:nvSpPr>
@@ -4755,7 +4681,7 @@
       </p:sp>
       <p:sp>
         <p:nvSpPr>
-          <p:cNvPr id="14" name="Text 11"/>
+          <p:cNvPr id="11" name="Text 9"/>
           <p:cNvSpPr txBox="1"/>
           <p:nvPr/>
         </p:nvSpPr>
@@ -4794,7 +4720,7 @@
       </p:sp>
       <p:sp>
         <p:nvSpPr>
-          <p:cNvPr id="15" name="Text 12"/>
+          <p:cNvPr id="12" name="Text 10"/>
           <p:cNvSpPr txBox="1"/>
           <p:nvPr/>
         </p:nvSpPr>
@@ -4833,7 +4759,7 @@
       </p:sp>
       <p:sp>
         <p:nvSpPr>
-          <p:cNvPr id="16" name="Shape 13"/>
+          <p:cNvPr id="13" name="Shape 11"/>
           <p:cNvSpPr/>
           <p:nvPr/>
         </p:nvSpPr>
@@ -4858,7 +4784,7 @@
       </p:sp>
       <p:sp>
         <p:nvSpPr>
-          <p:cNvPr id="17" name="Text 14"/>
+          <p:cNvPr id="14" name="Text 12"/>
           <p:cNvSpPr txBox="1"/>
           <p:nvPr/>
         </p:nvSpPr>
@@ -4897,7 +4823,7 @@
       </p:sp>
       <p:sp>
         <p:nvSpPr>
-          <p:cNvPr id="18" name="Text 15"/>
+          <p:cNvPr id="15" name="Text 13"/>
           <p:cNvSpPr txBox="1"/>
           <p:nvPr/>
         </p:nvSpPr>
@@ -4936,7 +4862,7 @@
       </p:sp>
       <p:sp>
         <p:nvSpPr>
-          <p:cNvPr id="19" name="Shape 16"/>
+          <p:cNvPr id="16" name="Shape 14"/>
           <p:cNvSpPr/>
           <p:nvPr/>
         </p:nvSpPr>
@@ -4961,7 +4887,7 @@
       </p:sp>
       <p:sp>
         <p:nvSpPr>
-          <p:cNvPr id="20" name="Text 17"/>
+          <p:cNvPr id="17" name="Text 15"/>
           <p:cNvSpPr txBox="1"/>
           <p:nvPr/>
         </p:nvSpPr>
@@ -5000,7 +4926,7 @@
       </p:sp>
       <p:sp>
         <p:nvSpPr>
-          <p:cNvPr id="21" name="Text 18"/>
+          <p:cNvPr id="18" name="Text 16"/>
           <p:cNvSpPr txBox="1"/>
           <p:nvPr/>
         </p:nvSpPr>
@@ -5039,7 +4965,7 @@
       </p:sp>
       <p:sp>
         <p:nvSpPr>
-          <p:cNvPr id="22" name="Text 19"/>
+          <p:cNvPr id="19" name="Text 17"/>
           <p:cNvSpPr txBox="1"/>
           <p:nvPr/>
         </p:nvSpPr>
@@ -5078,7 +5004,7 @@
       </p:sp>
       <p:sp>
         <p:nvSpPr>
-          <p:cNvPr id="23" name="Text 20"/>
+          <p:cNvPr id="20" name="Text 18"/>
           <p:cNvSpPr txBox="1"/>
           <p:nvPr/>
         </p:nvSpPr>
@@ -5117,7 +5043,7 @@
       </p:sp>
       <p:sp>
         <p:nvSpPr>
-          <p:cNvPr id="24" name="Text 21"/>
+          <p:cNvPr id="21" name="Text 19"/>
           <p:cNvSpPr txBox="1"/>
           <p:nvPr/>
         </p:nvSpPr>
@@ -5156,7 +5082,7 @@
       </p:sp>
       <p:sp>
         <p:nvSpPr>
-          <p:cNvPr id="25" name="Text 22"/>
+          <p:cNvPr id="22" name="Text 20"/>
           <p:cNvSpPr txBox="1"/>
           <p:nvPr/>
         </p:nvSpPr>
@@ -5195,7 +5121,7 @@
       </p:sp>
       <p:sp>
         <p:nvSpPr>
-          <p:cNvPr id="26" name="Text 23"/>
+          <p:cNvPr id="23" name="Text 21"/>
           <p:cNvSpPr txBox="1"/>
           <p:nvPr/>
         </p:nvSpPr>
@@ -5234,7 +5160,7 @@
       </p:sp>
       <p:sp>
         <p:nvSpPr>
-          <p:cNvPr id="27" name="Text 24"/>
+          <p:cNvPr id="24" name="Text 22"/>
           <p:cNvSpPr txBox="1"/>
           <p:nvPr/>
         </p:nvSpPr>
@@ -5273,7 +5199,7 @@
       </p:sp>
       <p:sp>
         <p:nvSpPr>
-          <p:cNvPr id="28" name="Shape 25"/>
+          <p:cNvPr id="25" name="Shape 23"/>
           <p:cNvSpPr/>
           <p:nvPr/>
         </p:nvSpPr>
@@ -5298,7 +5224,7 @@
       </p:sp>
       <p:sp>
         <p:nvSpPr>
-          <p:cNvPr id="29" name="Text 26"/>
+          <p:cNvPr id="26" name="Text 24"/>
           <p:cNvSpPr txBox="1"/>
           <p:nvPr/>
         </p:nvSpPr>
@@ -5346,6 +5272,54 @@
               <a:t>the sneaker, outdoor and youth sports homes, found by the apps they use and reached on 115MM CTV households, from a partner that owns the data, the supply and the creators.</a:t>
             </a:r>
             <a:endParaRPr lang="en-US" sz="950" dirty="0"/>
+          </a:p>
+        </p:txBody>
+      </p:sp>
+      <p:sp>
+        <p:nvSpPr>
+          <p:cNvPr id="25" name="Slide Number Placeholder 0"/>
+          <p:cNvSpPr>
+            <a:spLocks noGrp="1"/>
+          </p:cNvSpPr>
+          <p:nvPr>
+            <p:ph type="sldNum" sz="quarter" idx="4294967295"/>
+          </p:nvPr>
+        </p:nvSpPr>
+        <p:spPr>
+          <a:xfrm>
+            <a:off x="457200" y="4832604"/>
+            <a:ext cx="365760" cy="182880"/>
+          </a:xfrm>
+          <a:prstGeom prst="rect">
+            <a:avLst/>
+          </a:prstGeom>
+          <a:extLst>
+            <a:ext uri="{C572A759-6A51-4108-AA02-DFA0A04FC94B}">
+              <ma14:wrappingTextBoxFlag xmlns:ma14="http://schemas.microsoft.com/office/mac/drawingml/2011/main" val="0"/>
+            </a:ext>
+          </a:extLst>
+        </p:spPr>
+        <p:txBody>
+          <a:bodyPr lIns="0" tIns="0" rIns="0" bIns="0"/>
+          <a:lstStyle>
+            <a:lvl1pPr>
+              <a:defRPr sz="800">
+                <a:solidFill>
+                  <a:srgbClr val="7E7E7E"/>
+                </a:solidFill>
+                <a:latin typeface="Poppins SemiBold"/>
+                <a:ea typeface="Poppins SemiBold"/>
+                <a:cs typeface="Poppins SemiBold"/>
+              </a:defRPr>
+            </a:lvl1pPr>
+          </a:lstStyle>
+          <a:p>
+            <a:pPr algn="l"/>
+            <a:fld id="{F7021451-1387-4CA6-816F-3879F97B5CBC}" type="slidenum">
+              <a:rPr b="0" lang="en-US"/>
+              <a:t>4</a:t>
+            </a:fld>
+            <a:endParaRPr lang="en-US"/>
           </a:p>
         </p:txBody>
       </p:sp>
@@ -5360,13 +5334,6 @@
 <file path=ppt/slides/slide5.xml><?xml version="1.0" encoding="utf-8"?>
 <p:sld xmlns:a="http://schemas.openxmlformats.org/drawingml/2006/main" xmlns:r="http://schemas.openxmlformats.org/officeDocument/2006/relationships" xmlns:p="http://schemas.openxmlformats.org/presentationml/2006/main">
   <p:cSld name="Slide 5">
-    <p:bg>
-      <p:bgPr>
-        <a:solidFill>
-          <a:srgbClr val="1A1A1A"/>
-        </a:solidFill>
-      </p:bgPr>
-    </p:bg>
     <p:spTree>
       <p:nvGrpSpPr>
         <p:cNvPr id="1" name=""/>
@@ -5500,109 +5467,7 @@
       </p:sp>
       <p:sp>
         <p:nvSpPr>
-          <p:cNvPr id="5" name="Text 3"/>
-          <p:cNvSpPr txBox="1"/>
-          <p:nvPr/>
-        </p:nvSpPr>
-        <p:spPr>
-          <a:xfrm>
-            <a:off x="457200" y="4832604"/>
-            <a:ext cx="365760" cy="182880"/>
-          </a:xfrm>
-          <a:prstGeom prst="rect">
-            <a:avLst/>
-          </a:prstGeom>
-          <a:noFill/>
-          <a:ln/>
-        </p:spPr>
-        <p:txBody>
-          <a:bodyPr wrap="square" lIns="0" tIns="0" rIns="0" bIns="0" rtlCol="0" anchor="t"/>
-          <a:lstStyle/>
-          <a:p>
-            <a:pPr indent="0" marL="0">
-              <a:buNone/>
-            </a:pPr>
-            <a:r>
-              <a:rPr lang="en-US" sz="800" dirty="0">
-                <a:solidFill>
-                  <a:srgbClr val="7E7E7E"/>
-                </a:solidFill>
-                <a:latin typeface="Poppins SemiBold" pitchFamily="34" charset="0"/>
-                <a:ea typeface="Poppins SemiBold" pitchFamily="34" charset="-122"/>
-                <a:cs typeface="Poppins SemiBold" pitchFamily="34" charset="-120"/>
-              </a:rPr>
-              <a:t>5</a:t>
-            </a:r>
-            <a:endParaRPr lang="en-US" sz="800" dirty="0"/>
-          </a:p>
-        </p:txBody>
-      </p:sp>
-      <p:sp>
-        <p:nvSpPr>
-          <p:cNvPr id="6" name="Text 4"/>
-          <p:cNvSpPr txBox="1"/>
-          <p:nvPr/>
-        </p:nvSpPr>
-        <p:spPr>
-          <a:xfrm>
-            <a:off x="868680" y="4832604"/>
-            <a:ext cx="5486400" cy="182880"/>
-          </a:xfrm>
-          <a:prstGeom prst="rect">
-            <a:avLst/>
-          </a:prstGeom>
-          <a:noFill/>
-          <a:ln/>
-        </p:spPr>
-        <p:txBody>
-          <a:bodyPr wrap="square" lIns="0" tIns="0" rIns="0" bIns="0" rtlCol="0" anchor="t"/>
-          <a:lstStyle/>
-          <a:p>
-            <a:pPr indent="0" marL="0">
-              <a:buNone/>
-            </a:pPr>
-            <a:r>
-              <a:rPr lang="en-US" sz="700" dirty="0">
-                <a:solidFill>
-                  <a:srgbClr val="7E7E7E"/>
-                </a:solidFill>
-                <a:latin typeface="Poppins" pitchFamily="34" charset="0"/>
-                <a:ea typeface="Poppins" pitchFamily="34" charset="-122"/>
-                <a:cs typeface="Poppins" pitchFamily="34" charset="-120"/>
-              </a:rPr>
-              <a:t>Sabio × DICK'S  ·  Proactive point of view for Zenith  ·  Confidential</a:t>
-            </a:r>
-            <a:endParaRPr lang="en-US" sz="700" dirty="0"/>
-          </a:p>
-        </p:txBody>
-      </p:sp>
-      <p:pic>
-        <p:nvPicPr>
-          <p:cNvPr id="7" name="Image 0" descr="/home/claude/benjaminbring-cloud/sabio-deck-builders-/assets/sabio-logo-white-sm.png">    </p:cNvPr>
-          <p:cNvPicPr>
-            <a:picLocks noChangeAspect="1"/>
-          </p:cNvPicPr>
-          <p:nvPr/>
-        </p:nvPicPr>
-        <p:blipFill>
-          <a:blip r:embed="rId1"/>
-          <a:stretch>
-            <a:fillRect/>
-          </a:stretch>
-        </p:blipFill>
-        <p:spPr>
-          <a:xfrm>
-            <a:off x="8028432" y="4805172"/>
-            <a:ext cx="647572" cy="155448"/>
-          </a:xfrm>
-          <a:prstGeom prst="rect">
-            <a:avLst/>
-          </a:prstGeom>
-        </p:spPr>
-      </p:pic>
-      <p:sp>
-        <p:nvSpPr>
-          <p:cNvPr id="8" name="Shape 5"/>
+          <p:cNvPr id="5" name="Shape 3"/>
           <p:cNvSpPr/>
           <p:nvPr/>
         </p:nvSpPr>
@@ -5627,7 +5492,7 @@
       </p:sp>
       <p:sp>
         <p:nvSpPr>
-          <p:cNvPr id="9" name="Text 6"/>
+          <p:cNvPr id="6" name="Text 4"/>
           <p:cNvSpPr txBox="1"/>
           <p:nvPr/>
         </p:nvSpPr>
@@ -5666,7 +5531,7 @@
       </p:sp>
       <p:sp>
         <p:nvSpPr>
-          <p:cNvPr id="10" name="Text 7"/>
+          <p:cNvPr id="7" name="Text 5"/>
           <p:cNvSpPr txBox="1"/>
           <p:nvPr/>
         </p:nvSpPr>
@@ -5705,7 +5570,7 @@
       </p:sp>
       <p:sp>
         <p:nvSpPr>
-          <p:cNvPr id="11" name="Text 8"/>
+          <p:cNvPr id="8" name="Text 6"/>
           <p:cNvSpPr txBox="1"/>
           <p:nvPr/>
         </p:nvSpPr>
@@ -5744,7 +5609,7 @@
       </p:sp>
       <p:sp>
         <p:nvSpPr>
-          <p:cNvPr id="12" name="Text 9"/>
+          <p:cNvPr id="9" name="Text 7"/>
           <p:cNvSpPr txBox="1"/>
           <p:nvPr/>
         </p:nvSpPr>
@@ -5783,7 +5648,7 @@
       </p:sp>
       <p:sp>
         <p:nvSpPr>
-          <p:cNvPr id="13" name="Text 10"/>
+          <p:cNvPr id="10" name="Text 8"/>
           <p:cNvSpPr txBox="1"/>
           <p:nvPr/>
         </p:nvSpPr>
@@ -5822,7 +5687,7 @@
       </p:sp>
       <p:sp>
         <p:nvSpPr>
-          <p:cNvPr id="14" name="Text 11"/>
+          <p:cNvPr id="11" name="Text 9"/>
           <p:cNvSpPr txBox="1"/>
           <p:nvPr/>
         </p:nvSpPr>
@@ -5861,7 +5726,7 @@
       </p:sp>
       <p:sp>
         <p:nvSpPr>
-          <p:cNvPr id="15" name="Shape 12"/>
+          <p:cNvPr id="12" name="Shape 10"/>
           <p:cNvSpPr/>
           <p:nvPr/>
         </p:nvSpPr>
@@ -5886,7 +5751,7 @@
       </p:sp>
       <p:sp>
         <p:nvSpPr>
-          <p:cNvPr id="16" name="Text 13"/>
+          <p:cNvPr id="13" name="Text 11"/>
           <p:cNvSpPr txBox="1"/>
           <p:nvPr/>
         </p:nvSpPr>
@@ -5925,7 +5790,7 @@
       </p:sp>
       <p:sp>
         <p:nvSpPr>
-          <p:cNvPr id="17" name="Text 14"/>
+          <p:cNvPr id="14" name="Text 12"/>
           <p:cNvSpPr txBox="1"/>
           <p:nvPr/>
         </p:nvSpPr>
@@ -5964,7 +5829,7 @@
       </p:sp>
       <p:sp>
         <p:nvSpPr>
-          <p:cNvPr id="18" name="Shape 15"/>
+          <p:cNvPr id="15" name="Shape 13"/>
           <p:cNvSpPr/>
           <p:nvPr/>
         </p:nvSpPr>
@@ -5989,7 +5854,7 @@
       </p:sp>
       <p:sp>
         <p:nvSpPr>
-          <p:cNvPr id="19" name="Text 16"/>
+          <p:cNvPr id="16" name="Text 14"/>
           <p:cNvSpPr txBox="1"/>
           <p:nvPr/>
         </p:nvSpPr>
@@ -6028,7 +5893,7 @@
       </p:sp>
       <p:sp>
         <p:nvSpPr>
-          <p:cNvPr id="20" name="Text 17"/>
+          <p:cNvPr id="17" name="Text 15"/>
           <p:cNvSpPr txBox="1"/>
           <p:nvPr/>
         </p:nvSpPr>
@@ -6067,7 +5932,7 @@
       </p:sp>
       <p:sp>
         <p:nvSpPr>
-          <p:cNvPr id="21" name="Text 18"/>
+          <p:cNvPr id="18" name="Text 16"/>
           <p:cNvSpPr txBox="1"/>
           <p:nvPr/>
         </p:nvSpPr>
@@ -6106,7 +5971,7 @@
       </p:sp>
       <p:sp>
         <p:nvSpPr>
-          <p:cNvPr id="22" name="Text 19"/>
+          <p:cNvPr id="19" name="Text 17"/>
           <p:cNvSpPr txBox="1"/>
           <p:nvPr/>
         </p:nvSpPr>
@@ -6145,7 +6010,7 @@
       </p:sp>
       <p:sp>
         <p:nvSpPr>
-          <p:cNvPr id="23" name="Text 20"/>
+          <p:cNvPr id="20" name="Text 18"/>
           <p:cNvSpPr txBox="1"/>
           <p:nvPr/>
         </p:nvSpPr>
@@ -6184,7 +6049,7 @@
       </p:sp>
       <p:sp>
         <p:nvSpPr>
-          <p:cNvPr id="24" name="Text 21"/>
+          <p:cNvPr id="21" name="Text 19"/>
           <p:cNvSpPr txBox="1"/>
           <p:nvPr/>
         </p:nvSpPr>
@@ -6223,7 +6088,7 @@
       </p:sp>
       <p:sp>
         <p:nvSpPr>
-          <p:cNvPr id="25" name="Shape 22"/>
+          <p:cNvPr id="22" name="Shape 20"/>
           <p:cNvSpPr/>
           <p:nvPr/>
         </p:nvSpPr>
@@ -6248,7 +6113,7 @@
       </p:sp>
       <p:sp>
         <p:nvSpPr>
-          <p:cNvPr id="26" name="Text 23"/>
+          <p:cNvPr id="23" name="Text 21"/>
           <p:cNvSpPr txBox="1"/>
           <p:nvPr/>
         </p:nvSpPr>
@@ -6287,7 +6152,7 @@
       </p:sp>
       <p:sp>
         <p:nvSpPr>
-          <p:cNvPr id="27" name="Text 24"/>
+          <p:cNvPr id="24" name="Text 22"/>
           <p:cNvSpPr txBox="1"/>
           <p:nvPr/>
         </p:nvSpPr>
@@ -6326,7 +6191,7 @@
       </p:sp>
       <p:sp>
         <p:nvSpPr>
-          <p:cNvPr id="28" name="Shape 25"/>
+          <p:cNvPr id="25" name="Shape 23"/>
           <p:cNvSpPr/>
           <p:nvPr/>
         </p:nvSpPr>
@@ -6351,7 +6216,7 @@
       </p:sp>
       <p:sp>
         <p:nvSpPr>
-          <p:cNvPr id="29" name="Text 26"/>
+          <p:cNvPr id="26" name="Text 24"/>
           <p:cNvSpPr txBox="1"/>
           <p:nvPr/>
         </p:nvSpPr>
@@ -6390,7 +6255,7 @@
       </p:sp>
       <p:sp>
         <p:nvSpPr>
-          <p:cNvPr id="30" name="Text 27"/>
+          <p:cNvPr id="27" name="Text 25"/>
           <p:cNvSpPr txBox="1"/>
           <p:nvPr/>
         </p:nvSpPr>
@@ -6429,7 +6294,7 @@
       </p:sp>
       <p:sp>
         <p:nvSpPr>
-          <p:cNvPr id="31" name="Text 28"/>
+          <p:cNvPr id="28" name="Text 26"/>
           <p:cNvSpPr txBox="1"/>
           <p:nvPr/>
         </p:nvSpPr>
@@ -6468,7 +6333,7 @@
       </p:sp>
       <p:sp>
         <p:nvSpPr>
-          <p:cNvPr id="32" name="Text 29"/>
+          <p:cNvPr id="29" name="Text 27"/>
           <p:cNvSpPr txBox="1"/>
           <p:nvPr/>
         </p:nvSpPr>
@@ -6507,7 +6372,7 @@
       </p:sp>
       <p:sp>
         <p:nvSpPr>
-          <p:cNvPr id="33" name="Text 30"/>
+          <p:cNvPr id="30" name="Text 28"/>
           <p:cNvSpPr txBox="1"/>
           <p:nvPr/>
         </p:nvSpPr>
@@ -6546,7 +6411,7 @@
       </p:sp>
       <p:sp>
         <p:nvSpPr>
-          <p:cNvPr id="34" name="Text 31"/>
+          <p:cNvPr id="31" name="Text 29"/>
           <p:cNvSpPr txBox="1"/>
           <p:nvPr/>
         </p:nvSpPr>
@@ -6585,7 +6450,7 @@
       </p:sp>
       <p:sp>
         <p:nvSpPr>
-          <p:cNvPr id="35" name="Shape 32"/>
+          <p:cNvPr id="32" name="Shape 30"/>
           <p:cNvSpPr/>
           <p:nvPr/>
         </p:nvSpPr>
@@ -6610,7 +6475,7 @@
       </p:sp>
       <p:sp>
         <p:nvSpPr>
-          <p:cNvPr id="36" name="Text 33"/>
+          <p:cNvPr id="33" name="Text 31"/>
           <p:cNvSpPr txBox="1"/>
           <p:nvPr/>
         </p:nvSpPr>
@@ -6649,7 +6514,7 @@
       </p:sp>
       <p:sp>
         <p:nvSpPr>
-          <p:cNvPr id="37" name="Text 34"/>
+          <p:cNvPr id="34" name="Text 32"/>
           <p:cNvSpPr txBox="1"/>
           <p:nvPr/>
         </p:nvSpPr>
@@ -6683,6 +6548,54 @@
               <a:t>Sized at build [CONFIRM]</a:t>
             </a:r>
             <a:endParaRPr lang="en-US" sz="800" dirty="0"/>
+          </a:p>
+        </p:txBody>
+      </p:sp>
+      <p:sp>
+        <p:nvSpPr>
+          <p:cNvPr id="25" name="Slide Number Placeholder 0"/>
+          <p:cNvSpPr>
+            <a:spLocks noGrp="1"/>
+          </p:cNvSpPr>
+          <p:nvPr>
+            <p:ph type="sldNum" sz="quarter" idx="4294967295"/>
+          </p:nvPr>
+        </p:nvSpPr>
+        <p:spPr>
+          <a:xfrm>
+            <a:off x="457200" y="4832604"/>
+            <a:ext cx="365760" cy="182880"/>
+          </a:xfrm>
+          <a:prstGeom prst="rect">
+            <a:avLst/>
+          </a:prstGeom>
+          <a:extLst>
+            <a:ext uri="{C572A759-6A51-4108-AA02-DFA0A04FC94B}">
+              <ma14:wrappingTextBoxFlag xmlns:ma14="http://schemas.microsoft.com/office/mac/drawingml/2011/main" val="0"/>
+            </a:ext>
+          </a:extLst>
+        </p:spPr>
+        <p:txBody>
+          <a:bodyPr lIns="0" tIns="0" rIns="0" bIns="0"/>
+          <a:lstStyle>
+            <a:lvl1pPr>
+              <a:defRPr sz="800">
+                <a:solidFill>
+                  <a:srgbClr val="7E7E7E"/>
+                </a:solidFill>
+                <a:latin typeface="Poppins SemiBold"/>
+                <a:ea typeface="Poppins SemiBold"/>
+                <a:cs typeface="Poppins SemiBold"/>
+              </a:defRPr>
+            </a:lvl1pPr>
+          </a:lstStyle>
+          <a:p>
+            <a:pPr algn="l"/>
+            <a:fld id="{F7021451-1387-4CA6-816F-3879F97B5CBC}" type="slidenum">
+              <a:rPr b="0" lang="en-US"/>
+              <a:t>5</a:t>
+            </a:fld>
+            <a:endParaRPr lang="en-US"/>
           </a:p>
         </p:txBody>
       </p:sp>
@@ -6697,13 +6610,6 @@
 <file path=ppt/slides/slide6.xml><?xml version="1.0" encoding="utf-8"?>
 <p:sld xmlns:a="http://schemas.openxmlformats.org/drawingml/2006/main" xmlns:r="http://schemas.openxmlformats.org/officeDocument/2006/relationships" xmlns:p="http://schemas.openxmlformats.org/presentationml/2006/main">
   <p:cSld name="Slide 6">
-    <p:bg>
-      <p:bgPr>
-        <a:solidFill>
-          <a:srgbClr val="1A1A1A"/>
-        </a:solidFill>
-      </p:bgPr>
-    </p:bg>
     <p:spTree>
       <p:nvGrpSpPr>
         <p:cNvPr id="1" name=""/>
@@ -6837,109 +6743,7 @@
       </p:sp>
       <p:sp>
         <p:nvSpPr>
-          <p:cNvPr id="5" name="Text 3"/>
-          <p:cNvSpPr txBox="1"/>
-          <p:nvPr/>
-        </p:nvSpPr>
-        <p:spPr>
-          <a:xfrm>
-            <a:off x="457200" y="4832604"/>
-            <a:ext cx="365760" cy="182880"/>
-          </a:xfrm>
-          <a:prstGeom prst="rect">
-            <a:avLst/>
-          </a:prstGeom>
-          <a:noFill/>
-          <a:ln/>
-        </p:spPr>
-        <p:txBody>
-          <a:bodyPr wrap="square" lIns="0" tIns="0" rIns="0" bIns="0" rtlCol="0" anchor="t"/>
-          <a:lstStyle/>
-          <a:p>
-            <a:pPr indent="0" marL="0">
-              <a:buNone/>
-            </a:pPr>
-            <a:r>
-              <a:rPr lang="en-US" sz="800" dirty="0">
-                <a:solidFill>
-                  <a:srgbClr val="7E7E7E"/>
-                </a:solidFill>
-                <a:latin typeface="Poppins SemiBold" pitchFamily="34" charset="0"/>
-                <a:ea typeface="Poppins SemiBold" pitchFamily="34" charset="-122"/>
-                <a:cs typeface="Poppins SemiBold" pitchFamily="34" charset="-120"/>
-              </a:rPr>
-              <a:t>6</a:t>
-            </a:r>
-            <a:endParaRPr lang="en-US" sz="800" dirty="0"/>
-          </a:p>
-        </p:txBody>
-      </p:sp>
-      <p:sp>
-        <p:nvSpPr>
-          <p:cNvPr id="6" name="Text 4"/>
-          <p:cNvSpPr txBox="1"/>
-          <p:nvPr/>
-        </p:nvSpPr>
-        <p:spPr>
-          <a:xfrm>
-            <a:off x="868680" y="4832604"/>
-            <a:ext cx="5486400" cy="182880"/>
-          </a:xfrm>
-          <a:prstGeom prst="rect">
-            <a:avLst/>
-          </a:prstGeom>
-          <a:noFill/>
-          <a:ln/>
-        </p:spPr>
-        <p:txBody>
-          <a:bodyPr wrap="square" lIns="0" tIns="0" rIns="0" bIns="0" rtlCol="0" anchor="t"/>
-          <a:lstStyle/>
-          <a:p>
-            <a:pPr indent="0" marL="0">
-              <a:buNone/>
-            </a:pPr>
-            <a:r>
-              <a:rPr lang="en-US" sz="700" dirty="0">
-                <a:solidFill>
-                  <a:srgbClr val="7E7E7E"/>
-                </a:solidFill>
-                <a:latin typeface="Poppins" pitchFamily="34" charset="0"/>
-                <a:ea typeface="Poppins" pitchFamily="34" charset="-122"/>
-                <a:cs typeface="Poppins" pitchFamily="34" charset="-120"/>
-              </a:rPr>
-              <a:t>Sabio × DICK'S  ·  Proactive point of view for Zenith  ·  Confidential</a:t>
-            </a:r>
-            <a:endParaRPr lang="en-US" sz="700" dirty="0"/>
-          </a:p>
-        </p:txBody>
-      </p:sp>
-      <p:pic>
-        <p:nvPicPr>
-          <p:cNvPr id="7" name="Image 0" descr="/home/claude/benjaminbring-cloud/sabio-deck-builders-/assets/sabio-logo-white-sm.png">    </p:cNvPr>
-          <p:cNvPicPr>
-            <a:picLocks noChangeAspect="1"/>
-          </p:cNvPicPr>
-          <p:nvPr/>
-        </p:nvPicPr>
-        <p:blipFill>
-          <a:blip r:embed="rId1"/>
-          <a:stretch>
-            <a:fillRect/>
-          </a:stretch>
-        </p:blipFill>
-        <p:spPr>
-          <a:xfrm>
-            <a:off x="8028432" y="4805172"/>
-            <a:ext cx="647572" cy="155448"/>
-          </a:xfrm>
-          <a:prstGeom prst="rect">
-            <a:avLst/>
-          </a:prstGeom>
-        </p:spPr>
-      </p:pic>
-      <p:sp>
-        <p:nvSpPr>
-          <p:cNvPr id="8" name="Shape 5"/>
+          <p:cNvPr id="5" name="Shape 3"/>
           <p:cNvSpPr/>
           <p:nvPr/>
         </p:nvSpPr>
@@ -6964,7 +6768,7 @@
       </p:sp>
       <p:sp>
         <p:nvSpPr>
-          <p:cNvPr id="9" name="Text 6"/>
+          <p:cNvPr id="6" name="Text 4"/>
           <p:cNvSpPr txBox="1"/>
           <p:nvPr/>
         </p:nvSpPr>
@@ -7003,7 +6807,7 @@
       </p:sp>
       <p:sp>
         <p:nvSpPr>
-          <p:cNvPr id="10" name="Text 7"/>
+          <p:cNvPr id="7" name="Text 5"/>
           <p:cNvSpPr txBox="1"/>
           <p:nvPr/>
         </p:nvSpPr>
@@ -7042,7 +6846,7 @@
       </p:sp>
       <p:sp>
         <p:nvSpPr>
-          <p:cNvPr id="11" name="Shape 8"/>
+          <p:cNvPr id="8" name="Shape 6"/>
           <p:cNvSpPr/>
           <p:nvPr/>
         </p:nvSpPr>
@@ -7067,7 +6871,7 @@
       </p:sp>
       <p:sp>
         <p:nvSpPr>
-          <p:cNvPr id="12" name="Text 9"/>
+          <p:cNvPr id="9" name="Text 7"/>
           <p:cNvSpPr txBox="1"/>
           <p:nvPr/>
         </p:nvSpPr>
@@ -7106,7 +6910,7 @@
       </p:sp>
       <p:sp>
         <p:nvSpPr>
-          <p:cNvPr id="13" name="Text 10"/>
+          <p:cNvPr id="10" name="Text 8"/>
           <p:cNvSpPr txBox="1"/>
           <p:nvPr/>
         </p:nvSpPr>
@@ -7145,7 +6949,7 @@
       </p:sp>
       <p:sp>
         <p:nvSpPr>
-          <p:cNvPr id="14" name="Shape 11"/>
+          <p:cNvPr id="11" name="Shape 9"/>
           <p:cNvSpPr/>
           <p:nvPr/>
         </p:nvSpPr>
@@ -7170,7 +6974,7 @@
       </p:sp>
       <p:sp>
         <p:nvSpPr>
-          <p:cNvPr id="15" name="Text 12"/>
+          <p:cNvPr id="12" name="Text 10"/>
           <p:cNvSpPr txBox="1"/>
           <p:nvPr/>
         </p:nvSpPr>
@@ -7209,7 +7013,7 @@
       </p:sp>
       <p:sp>
         <p:nvSpPr>
-          <p:cNvPr id="16" name="Text 13"/>
+          <p:cNvPr id="13" name="Text 11"/>
           <p:cNvSpPr txBox="1"/>
           <p:nvPr/>
         </p:nvSpPr>
@@ -7248,7 +7052,7 @@
       </p:sp>
       <p:sp>
         <p:nvSpPr>
-          <p:cNvPr id="17" name="Shape 14"/>
+          <p:cNvPr id="14" name="Shape 12"/>
           <p:cNvSpPr/>
           <p:nvPr/>
         </p:nvSpPr>
@@ -7273,7 +7077,7 @@
       </p:sp>
       <p:sp>
         <p:nvSpPr>
-          <p:cNvPr id="18" name="Text 15"/>
+          <p:cNvPr id="15" name="Text 13"/>
           <p:cNvSpPr txBox="1"/>
           <p:nvPr/>
         </p:nvSpPr>
@@ -7312,7 +7116,7 @@
       </p:sp>
       <p:sp>
         <p:nvSpPr>
-          <p:cNvPr id="19" name="Text 16"/>
+          <p:cNvPr id="16" name="Text 14"/>
           <p:cNvSpPr txBox="1"/>
           <p:nvPr/>
         </p:nvSpPr>
@@ -7351,7 +7155,7 @@
       </p:sp>
       <p:sp>
         <p:nvSpPr>
-          <p:cNvPr id="20" name="Shape 17"/>
+          <p:cNvPr id="17" name="Shape 15"/>
           <p:cNvSpPr/>
           <p:nvPr/>
         </p:nvSpPr>
@@ -7376,7 +7180,7 @@
       </p:sp>
       <p:sp>
         <p:nvSpPr>
-          <p:cNvPr id="21" name="Text 18"/>
+          <p:cNvPr id="18" name="Text 16"/>
           <p:cNvSpPr txBox="1"/>
           <p:nvPr/>
         </p:nvSpPr>
@@ -7415,7 +7219,7 @@
       </p:sp>
       <p:sp>
         <p:nvSpPr>
-          <p:cNvPr id="22" name="Text 19"/>
+          <p:cNvPr id="19" name="Text 17"/>
           <p:cNvSpPr txBox="1"/>
           <p:nvPr/>
         </p:nvSpPr>
@@ -7537,6 +7341,54 @@
               <a:t>Weekly pacing, with a store visit read on the same graph</a:t>
             </a:r>
             <a:endParaRPr lang="en-US" sz="950" dirty="0"/>
+          </a:p>
+        </p:txBody>
+      </p:sp>
+      <p:sp>
+        <p:nvSpPr>
+          <p:cNvPr id="25" name="Slide Number Placeholder 0"/>
+          <p:cNvSpPr>
+            <a:spLocks noGrp="1"/>
+          </p:cNvSpPr>
+          <p:nvPr>
+            <p:ph type="sldNum" sz="quarter" idx="4294967295"/>
+          </p:nvPr>
+        </p:nvSpPr>
+        <p:spPr>
+          <a:xfrm>
+            <a:off x="457200" y="4832604"/>
+            <a:ext cx="365760" cy="182880"/>
+          </a:xfrm>
+          <a:prstGeom prst="rect">
+            <a:avLst/>
+          </a:prstGeom>
+          <a:extLst>
+            <a:ext uri="{C572A759-6A51-4108-AA02-DFA0A04FC94B}">
+              <ma14:wrappingTextBoxFlag xmlns:ma14="http://schemas.microsoft.com/office/mac/drawingml/2011/main" val="0"/>
+            </a:ext>
+          </a:extLst>
+        </p:spPr>
+        <p:txBody>
+          <a:bodyPr lIns="0" tIns="0" rIns="0" bIns="0"/>
+          <a:lstStyle>
+            <a:lvl1pPr>
+              <a:defRPr sz="800">
+                <a:solidFill>
+                  <a:srgbClr val="7E7E7E"/>
+                </a:solidFill>
+                <a:latin typeface="Poppins SemiBold"/>
+                <a:ea typeface="Poppins SemiBold"/>
+                <a:cs typeface="Poppins SemiBold"/>
+              </a:defRPr>
+            </a:lvl1pPr>
+          </a:lstStyle>
+          <a:p>
+            <a:pPr algn="l"/>
+            <a:fld id="{F7021451-1387-4CA6-816F-3879F97B5CBC}" type="slidenum">
+              <a:rPr b="0" lang="en-US"/>
+              <a:t>6</a:t>
+            </a:fld>
+            <a:endParaRPr lang="en-US"/>
           </a:p>
         </p:txBody>
       </p:sp>
@@ -7551,13 +7403,6 @@
 <file path=ppt/slides/slide7.xml><?xml version="1.0" encoding="utf-8"?>
 <p:sld xmlns:a="http://schemas.openxmlformats.org/drawingml/2006/main" xmlns:r="http://schemas.openxmlformats.org/officeDocument/2006/relationships" xmlns:p="http://schemas.openxmlformats.org/presentationml/2006/main">
   <p:cSld name="Slide 7">
-    <p:bg>
-      <p:bgPr>
-        <a:solidFill>
-          <a:srgbClr val="1A1A1A"/>
-        </a:solidFill>
-      </p:bgPr>
-    </p:bg>
     <p:spTree>
       <p:nvGrpSpPr>
         <p:cNvPr id="1" name=""/>
@@ -7691,109 +7536,7 @@
       </p:sp>
       <p:sp>
         <p:nvSpPr>
-          <p:cNvPr id="5" name="Text 3"/>
-          <p:cNvSpPr txBox="1"/>
-          <p:nvPr/>
-        </p:nvSpPr>
-        <p:spPr>
-          <a:xfrm>
-            <a:off x="457200" y="4832604"/>
-            <a:ext cx="365760" cy="182880"/>
-          </a:xfrm>
-          <a:prstGeom prst="rect">
-            <a:avLst/>
-          </a:prstGeom>
-          <a:noFill/>
-          <a:ln/>
-        </p:spPr>
-        <p:txBody>
-          <a:bodyPr wrap="square" lIns="0" tIns="0" rIns="0" bIns="0" rtlCol="0" anchor="t"/>
-          <a:lstStyle/>
-          <a:p>
-            <a:pPr indent="0" marL="0">
-              <a:buNone/>
-            </a:pPr>
-            <a:r>
-              <a:rPr lang="en-US" sz="800" dirty="0">
-                <a:solidFill>
-                  <a:srgbClr val="7E7E7E"/>
-                </a:solidFill>
-                <a:latin typeface="Poppins SemiBold" pitchFamily="34" charset="0"/>
-                <a:ea typeface="Poppins SemiBold" pitchFamily="34" charset="-122"/>
-                <a:cs typeface="Poppins SemiBold" pitchFamily="34" charset="-120"/>
-              </a:rPr>
-              <a:t>7</a:t>
-            </a:r>
-            <a:endParaRPr lang="en-US" sz="800" dirty="0"/>
-          </a:p>
-        </p:txBody>
-      </p:sp>
-      <p:sp>
-        <p:nvSpPr>
-          <p:cNvPr id="6" name="Text 4"/>
-          <p:cNvSpPr txBox="1"/>
-          <p:nvPr/>
-        </p:nvSpPr>
-        <p:spPr>
-          <a:xfrm>
-            <a:off x="868680" y="4832604"/>
-            <a:ext cx="5486400" cy="182880"/>
-          </a:xfrm>
-          <a:prstGeom prst="rect">
-            <a:avLst/>
-          </a:prstGeom>
-          <a:noFill/>
-          <a:ln/>
-        </p:spPr>
-        <p:txBody>
-          <a:bodyPr wrap="square" lIns="0" tIns="0" rIns="0" bIns="0" rtlCol="0" anchor="t"/>
-          <a:lstStyle/>
-          <a:p>
-            <a:pPr indent="0" marL="0">
-              <a:buNone/>
-            </a:pPr>
-            <a:r>
-              <a:rPr lang="en-US" sz="700" dirty="0">
-                <a:solidFill>
-                  <a:srgbClr val="7E7E7E"/>
-                </a:solidFill>
-                <a:latin typeface="Poppins" pitchFamily="34" charset="0"/>
-                <a:ea typeface="Poppins" pitchFamily="34" charset="-122"/>
-                <a:cs typeface="Poppins" pitchFamily="34" charset="-120"/>
-              </a:rPr>
-              <a:t>Sabio × DICK'S  ·  Proactive point of view for Zenith  ·  Confidential</a:t>
-            </a:r>
-            <a:endParaRPr lang="en-US" sz="700" dirty="0"/>
-          </a:p>
-        </p:txBody>
-      </p:sp>
-      <p:pic>
-        <p:nvPicPr>
-          <p:cNvPr id="7" name="Image 0" descr="/home/claude/benjaminbring-cloud/sabio-deck-builders-/assets/sabio-logo-white-sm.png">    </p:cNvPr>
-          <p:cNvPicPr>
-            <a:picLocks noChangeAspect="1"/>
-          </p:cNvPicPr>
-          <p:nvPr/>
-        </p:nvPicPr>
-        <p:blipFill>
-          <a:blip r:embed="rId1"/>
-          <a:stretch>
-            <a:fillRect/>
-          </a:stretch>
-        </p:blipFill>
-        <p:spPr>
-          <a:xfrm>
-            <a:off x="8028432" y="4805172"/>
-            <a:ext cx="647572" cy="155448"/>
-          </a:xfrm>
-          <a:prstGeom prst="rect">
-            <a:avLst/>
-          </a:prstGeom>
-        </p:spPr>
-      </p:pic>
-      <p:sp>
-        <p:nvSpPr>
-          <p:cNvPr id="8" name="Shape 5"/>
+          <p:cNvPr id="5" name="Shape 3"/>
           <p:cNvSpPr/>
           <p:nvPr/>
         </p:nvSpPr>
@@ -7818,7 +7561,7 @@
       </p:sp>
       <p:sp>
         <p:nvSpPr>
-          <p:cNvPr id="9" name="Text 6"/>
+          <p:cNvPr id="6" name="Text 4"/>
           <p:cNvSpPr txBox="1"/>
           <p:nvPr/>
         </p:nvSpPr>
@@ -7857,7 +7600,7 @@
       </p:sp>
       <p:sp>
         <p:nvSpPr>
-          <p:cNvPr id="10" name="Text 7"/>
+          <p:cNvPr id="7" name="Text 5"/>
           <p:cNvSpPr txBox="1"/>
           <p:nvPr/>
         </p:nvSpPr>
@@ -7896,7 +7639,7 @@
       </p:sp>
       <p:sp>
         <p:nvSpPr>
-          <p:cNvPr id="11" name="Shape 8"/>
+          <p:cNvPr id="8" name="Shape 6"/>
           <p:cNvSpPr/>
           <p:nvPr/>
         </p:nvSpPr>
@@ -7921,7 +7664,7 @@
       </p:sp>
       <p:sp>
         <p:nvSpPr>
-          <p:cNvPr id="12" name="Text 9"/>
+          <p:cNvPr id="9" name="Text 7"/>
           <p:cNvSpPr txBox="1"/>
           <p:nvPr/>
         </p:nvSpPr>
@@ -7960,7 +7703,7 @@
       </p:sp>
       <p:sp>
         <p:nvSpPr>
-          <p:cNvPr id="13" name="Text 10"/>
+          <p:cNvPr id="10" name="Text 8"/>
           <p:cNvSpPr txBox="1"/>
           <p:nvPr/>
         </p:nvSpPr>
@@ -7999,7 +7742,7 @@
       </p:sp>
       <p:sp>
         <p:nvSpPr>
-          <p:cNvPr id="14" name="Shape 11"/>
+          <p:cNvPr id="11" name="Shape 9"/>
           <p:cNvSpPr/>
           <p:nvPr/>
         </p:nvSpPr>
@@ -8024,7 +7767,7 @@
       </p:sp>
       <p:sp>
         <p:nvSpPr>
-          <p:cNvPr id="15" name="Text 12"/>
+          <p:cNvPr id="12" name="Text 10"/>
           <p:cNvSpPr txBox="1"/>
           <p:nvPr/>
         </p:nvSpPr>
@@ -8063,7 +7806,7 @@
       </p:sp>
       <p:sp>
         <p:nvSpPr>
-          <p:cNvPr id="16" name="Text 13"/>
+          <p:cNvPr id="13" name="Text 11"/>
           <p:cNvSpPr txBox="1"/>
           <p:nvPr/>
         </p:nvSpPr>
@@ -8102,7 +7845,7 @@
       </p:sp>
       <p:sp>
         <p:nvSpPr>
-          <p:cNvPr id="17" name="Shape 14"/>
+          <p:cNvPr id="14" name="Shape 12"/>
           <p:cNvSpPr/>
           <p:nvPr/>
         </p:nvSpPr>
@@ -8127,7 +7870,7 @@
       </p:sp>
       <p:sp>
         <p:nvSpPr>
-          <p:cNvPr id="18" name="Text 15"/>
+          <p:cNvPr id="15" name="Text 13"/>
           <p:cNvSpPr txBox="1"/>
           <p:nvPr/>
         </p:nvSpPr>
@@ -8166,7 +7909,7 @@
       </p:sp>
       <p:sp>
         <p:nvSpPr>
-          <p:cNvPr id="19" name="Text 16"/>
+          <p:cNvPr id="16" name="Text 14"/>
           <p:cNvSpPr txBox="1"/>
           <p:nvPr/>
         </p:nvSpPr>
@@ -8205,7 +7948,7 @@
       </p:sp>
       <p:sp>
         <p:nvSpPr>
-          <p:cNvPr id="20" name="Shape 17"/>
+          <p:cNvPr id="17" name="Shape 15"/>
           <p:cNvSpPr/>
           <p:nvPr/>
         </p:nvSpPr>
@@ -8230,7 +7973,7 @@
       </p:sp>
       <p:sp>
         <p:nvSpPr>
-          <p:cNvPr id="21" name="Text 18"/>
+          <p:cNvPr id="18" name="Text 16"/>
           <p:cNvSpPr txBox="1"/>
           <p:nvPr/>
         </p:nvSpPr>
@@ -8269,7 +8012,7 @@
       </p:sp>
       <p:sp>
         <p:nvSpPr>
-          <p:cNvPr id="22" name="Text 19"/>
+          <p:cNvPr id="19" name="Text 17"/>
           <p:cNvSpPr txBox="1"/>
           <p:nvPr/>
         </p:nvSpPr>
@@ -8308,7 +8051,7 @@
       </p:sp>
       <p:sp>
         <p:nvSpPr>
-          <p:cNvPr id="23" name="Shape 20"/>
+          <p:cNvPr id="20" name="Shape 18"/>
           <p:cNvSpPr/>
           <p:nvPr/>
         </p:nvSpPr>
@@ -8333,7 +8076,7 @@
       </p:sp>
       <p:sp>
         <p:nvSpPr>
-          <p:cNvPr id="24" name="Text 21"/>
+          <p:cNvPr id="21" name="Text 19"/>
           <p:cNvSpPr txBox="1"/>
           <p:nvPr/>
         </p:nvSpPr>
@@ -8372,7 +8115,7 @@
       </p:sp>
       <p:sp>
         <p:nvSpPr>
-          <p:cNvPr id="25" name="Text 22"/>
+          <p:cNvPr id="22" name="Text 20"/>
           <p:cNvSpPr txBox="1"/>
           <p:nvPr/>
         </p:nvSpPr>
@@ -8406,6 +8149,54 @@
               <a:t>Sabio is minority-owned, so this spend counts toward DICK'S and Publicis supplier diversity goals.</a:t>
             </a:r>
             <a:endParaRPr lang="en-US" sz="850" dirty="0"/>
+          </a:p>
+        </p:txBody>
+      </p:sp>
+      <p:sp>
+        <p:nvSpPr>
+          <p:cNvPr id="25" name="Slide Number Placeholder 0"/>
+          <p:cNvSpPr>
+            <a:spLocks noGrp="1"/>
+          </p:cNvSpPr>
+          <p:nvPr>
+            <p:ph type="sldNum" sz="quarter" idx="4294967295"/>
+          </p:nvPr>
+        </p:nvSpPr>
+        <p:spPr>
+          <a:xfrm>
+            <a:off x="457200" y="4832604"/>
+            <a:ext cx="365760" cy="182880"/>
+          </a:xfrm>
+          <a:prstGeom prst="rect">
+            <a:avLst/>
+          </a:prstGeom>
+          <a:extLst>
+            <a:ext uri="{C572A759-6A51-4108-AA02-DFA0A04FC94B}">
+              <ma14:wrappingTextBoxFlag xmlns:ma14="http://schemas.microsoft.com/office/mac/drawingml/2011/main" val="0"/>
+            </a:ext>
+          </a:extLst>
+        </p:spPr>
+        <p:txBody>
+          <a:bodyPr lIns="0" tIns="0" rIns="0" bIns="0"/>
+          <a:lstStyle>
+            <a:lvl1pPr>
+              <a:defRPr sz="800">
+                <a:solidFill>
+                  <a:srgbClr val="7E7E7E"/>
+                </a:solidFill>
+                <a:latin typeface="Poppins SemiBold"/>
+                <a:ea typeface="Poppins SemiBold"/>
+                <a:cs typeface="Poppins SemiBold"/>
+              </a:defRPr>
+            </a:lvl1pPr>
+          </a:lstStyle>
+          <a:p>
+            <a:pPr algn="l"/>
+            <a:fld id="{F7021451-1387-4CA6-816F-3879F97B5CBC}" type="slidenum">
+              <a:rPr b="0" lang="en-US"/>
+              <a:t>7</a:t>
+            </a:fld>
+            <a:endParaRPr lang="en-US"/>
           </a:p>
         </p:txBody>
       </p:sp>
@@ -8420,13 +8211,6 @@
 <file path=ppt/slides/slide8.xml><?xml version="1.0" encoding="utf-8"?>
 <p:sld xmlns:a="http://schemas.openxmlformats.org/drawingml/2006/main" xmlns:r="http://schemas.openxmlformats.org/officeDocument/2006/relationships" xmlns:p="http://schemas.openxmlformats.org/presentationml/2006/main">
   <p:cSld name="Slide 8">
-    <p:bg>
-      <p:bgPr>
-        <a:solidFill>
-          <a:srgbClr val="1A1A1A"/>
-        </a:solidFill>
-      </p:bgPr>
-    </p:bg>
     <p:spTree>
       <p:nvGrpSpPr>
         <p:cNvPr id="1" name=""/>
@@ -8560,109 +8344,7 @@
       </p:sp>
       <p:sp>
         <p:nvSpPr>
-          <p:cNvPr id="5" name="Text 3"/>
-          <p:cNvSpPr txBox="1"/>
-          <p:nvPr/>
-        </p:nvSpPr>
-        <p:spPr>
-          <a:xfrm>
-            <a:off x="457200" y="4832604"/>
-            <a:ext cx="365760" cy="182880"/>
-          </a:xfrm>
-          <a:prstGeom prst="rect">
-            <a:avLst/>
-          </a:prstGeom>
-          <a:noFill/>
-          <a:ln/>
-        </p:spPr>
-        <p:txBody>
-          <a:bodyPr wrap="square" lIns="0" tIns="0" rIns="0" bIns="0" rtlCol="0" anchor="t"/>
-          <a:lstStyle/>
-          <a:p>
-            <a:pPr indent="0" marL="0">
-              <a:buNone/>
-            </a:pPr>
-            <a:r>
-              <a:rPr lang="en-US" sz="800" dirty="0">
-                <a:solidFill>
-                  <a:srgbClr val="7E7E7E"/>
-                </a:solidFill>
-                <a:latin typeface="Poppins SemiBold" pitchFamily="34" charset="0"/>
-                <a:ea typeface="Poppins SemiBold" pitchFamily="34" charset="-122"/>
-                <a:cs typeface="Poppins SemiBold" pitchFamily="34" charset="-120"/>
-              </a:rPr>
-              <a:t>8</a:t>
-            </a:r>
-            <a:endParaRPr lang="en-US" sz="800" dirty="0"/>
-          </a:p>
-        </p:txBody>
-      </p:sp>
-      <p:sp>
-        <p:nvSpPr>
-          <p:cNvPr id="6" name="Text 4"/>
-          <p:cNvSpPr txBox="1"/>
-          <p:nvPr/>
-        </p:nvSpPr>
-        <p:spPr>
-          <a:xfrm>
-            <a:off x="868680" y="4832604"/>
-            <a:ext cx="5486400" cy="182880"/>
-          </a:xfrm>
-          <a:prstGeom prst="rect">
-            <a:avLst/>
-          </a:prstGeom>
-          <a:noFill/>
-          <a:ln/>
-        </p:spPr>
-        <p:txBody>
-          <a:bodyPr wrap="square" lIns="0" tIns="0" rIns="0" bIns="0" rtlCol="0" anchor="t"/>
-          <a:lstStyle/>
-          <a:p>
-            <a:pPr indent="0" marL="0">
-              <a:buNone/>
-            </a:pPr>
-            <a:r>
-              <a:rPr lang="en-US" sz="700" dirty="0">
-                <a:solidFill>
-                  <a:srgbClr val="7E7E7E"/>
-                </a:solidFill>
-                <a:latin typeface="Poppins" pitchFamily="34" charset="0"/>
-                <a:ea typeface="Poppins" pitchFamily="34" charset="-122"/>
-                <a:cs typeface="Poppins" pitchFamily="34" charset="-120"/>
-              </a:rPr>
-              <a:t>Sabio × DICK'S  ·  Proactive point of view for Zenith  ·  Confidential</a:t>
-            </a:r>
-            <a:endParaRPr lang="en-US" sz="700" dirty="0"/>
-          </a:p>
-        </p:txBody>
-      </p:sp>
-      <p:pic>
-        <p:nvPicPr>
-          <p:cNvPr id="7" name="Image 0" descr="/home/claude/benjaminbring-cloud/sabio-deck-builders-/assets/sabio-logo-white-sm.png">    </p:cNvPr>
-          <p:cNvPicPr>
-            <a:picLocks noChangeAspect="1"/>
-          </p:cNvPicPr>
-          <p:nvPr/>
-        </p:nvPicPr>
-        <p:blipFill>
-          <a:blip r:embed="rId1"/>
-          <a:stretch>
-            <a:fillRect/>
-          </a:stretch>
-        </p:blipFill>
-        <p:spPr>
-          <a:xfrm>
-            <a:off x="8028432" y="4805172"/>
-            <a:ext cx="647572" cy="155448"/>
-          </a:xfrm>
-          <a:prstGeom prst="rect">
-            <a:avLst/>
-          </a:prstGeom>
-        </p:spPr>
-      </p:pic>
-      <p:sp>
-        <p:nvSpPr>
-          <p:cNvPr id="8" name="Shape 5"/>
+          <p:cNvPr id="5" name="Shape 3"/>
           <p:cNvSpPr/>
           <p:nvPr/>
         </p:nvSpPr>
@@ -8687,7 +8369,7 @@
       </p:sp>
       <p:sp>
         <p:nvSpPr>
-          <p:cNvPr id="9" name="Text 6"/>
+          <p:cNvPr id="6" name="Text 4"/>
           <p:cNvSpPr txBox="1"/>
           <p:nvPr/>
         </p:nvSpPr>
@@ -8726,7 +8408,7 @@
       </p:sp>
       <p:sp>
         <p:nvSpPr>
-          <p:cNvPr id="10" name="Text 7"/>
+          <p:cNvPr id="7" name="Text 5"/>
           <p:cNvSpPr txBox="1"/>
           <p:nvPr/>
         </p:nvSpPr>
@@ -8765,7 +8447,7 @@
       </p:sp>
       <p:sp>
         <p:nvSpPr>
-          <p:cNvPr id="11" name="Text 8"/>
+          <p:cNvPr id="8" name="Text 6"/>
           <p:cNvSpPr txBox="1"/>
           <p:nvPr/>
         </p:nvSpPr>
@@ -8804,7 +8486,7 @@
       </p:sp>
       <p:sp>
         <p:nvSpPr>
-          <p:cNvPr id="12" name="Shape 9"/>
+          <p:cNvPr id="9" name="Shape 7"/>
           <p:cNvSpPr/>
           <p:nvPr/>
         </p:nvSpPr>
@@ -8829,7 +8511,7 @@
       </p:sp>
       <p:sp>
         <p:nvSpPr>
-          <p:cNvPr id="13" name="Text 10"/>
+          <p:cNvPr id="10" name="Text 8"/>
           <p:cNvSpPr txBox="1"/>
           <p:nvPr/>
         </p:nvSpPr>
@@ -8868,7 +8550,7 @@
       </p:sp>
       <p:sp>
         <p:nvSpPr>
-          <p:cNvPr id="14" name="Text 11"/>
+          <p:cNvPr id="11" name="Text 9"/>
           <p:cNvSpPr txBox="1"/>
           <p:nvPr/>
         </p:nvSpPr>
@@ -8907,7 +8589,7 @@
       </p:sp>
       <p:sp>
         <p:nvSpPr>
-          <p:cNvPr id="15" name="Text 12"/>
+          <p:cNvPr id="12" name="Text 10"/>
           <p:cNvSpPr txBox="1"/>
           <p:nvPr/>
         </p:nvSpPr>
@@ -8946,7 +8628,7 @@
       </p:sp>
       <p:sp>
         <p:nvSpPr>
-          <p:cNvPr id="16" name="Shape 13"/>
+          <p:cNvPr id="13" name="Shape 11"/>
           <p:cNvSpPr/>
           <p:nvPr/>
         </p:nvSpPr>
@@ -8971,7 +8653,7 @@
       </p:sp>
       <p:sp>
         <p:nvSpPr>
-          <p:cNvPr id="17" name="Text 14"/>
+          <p:cNvPr id="14" name="Text 12"/>
           <p:cNvSpPr txBox="1"/>
           <p:nvPr/>
         </p:nvSpPr>
@@ -9010,7 +8692,7 @@
       </p:sp>
       <p:sp>
         <p:nvSpPr>
-          <p:cNvPr id="18" name="Text 15"/>
+          <p:cNvPr id="15" name="Text 13"/>
           <p:cNvSpPr txBox="1"/>
           <p:nvPr/>
         </p:nvSpPr>
@@ -9049,7 +8731,7 @@
       </p:sp>
       <p:sp>
         <p:nvSpPr>
-          <p:cNvPr id="19" name="Text 16"/>
+          <p:cNvPr id="16" name="Text 14"/>
           <p:cNvSpPr txBox="1"/>
           <p:nvPr/>
         </p:nvSpPr>
@@ -9088,7 +8770,7 @@
       </p:sp>
       <p:sp>
         <p:nvSpPr>
-          <p:cNvPr id="20" name="Shape 17"/>
+          <p:cNvPr id="17" name="Shape 15"/>
           <p:cNvSpPr/>
           <p:nvPr/>
         </p:nvSpPr>
@@ -9113,7 +8795,7 @@
       </p:sp>
       <p:sp>
         <p:nvSpPr>
-          <p:cNvPr id="21" name="Text 18"/>
+          <p:cNvPr id="18" name="Text 16"/>
           <p:cNvSpPr txBox="1"/>
           <p:nvPr/>
         </p:nvSpPr>
@@ -9152,7 +8834,7 @@
       </p:sp>
       <p:sp>
         <p:nvSpPr>
-          <p:cNvPr id="22" name="Text 19"/>
+          <p:cNvPr id="19" name="Text 17"/>
           <p:cNvSpPr txBox="1"/>
           <p:nvPr/>
         </p:nvSpPr>
@@ -9247,6 +8929,54 @@
               <a:t>That said, it only works if we start before the first gifting weekend, so timing matters more than size here.</a:t>
             </a:r>
             <a:endParaRPr lang="en-US" sz="950" dirty="0"/>
+          </a:p>
+        </p:txBody>
+      </p:sp>
+      <p:sp>
+        <p:nvSpPr>
+          <p:cNvPr id="25" name="Slide Number Placeholder 0"/>
+          <p:cNvSpPr>
+            <a:spLocks noGrp="1"/>
+          </p:cNvSpPr>
+          <p:nvPr>
+            <p:ph type="sldNum" sz="quarter" idx="4294967295"/>
+          </p:nvPr>
+        </p:nvSpPr>
+        <p:spPr>
+          <a:xfrm>
+            <a:off x="457200" y="4832604"/>
+            <a:ext cx="365760" cy="182880"/>
+          </a:xfrm>
+          <a:prstGeom prst="rect">
+            <a:avLst/>
+          </a:prstGeom>
+          <a:extLst>
+            <a:ext uri="{C572A759-6A51-4108-AA02-DFA0A04FC94B}">
+              <ma14:wrappingTextBoxFlag xmlns:ma14="http://schemas.microsoft.com/office/mac/drawingml/2011/main" val="0"/>
+            </a:ext>
+          </a:extLst>
+        </p:spPr>
+        <p:txBody>
+          <a:bodyPr lIns="0" tIns="0" rIns="0" bIns="0"/>
+          <a:lstStyle>
+            <a:lvl1pPr>
+              <a:defRPr sz="800">
+                <a:solidFill>
+                  <a:srgbClr val="7E7E7E"/>
+                </a:solidFill>
+                <a:latin typeface="Poppins SemiBold"/>
+                <a:ea typeface="Poppins SemiBold"/>
+                <a:cs typeface="Poppins SemiBold"/>
+              </a:defRPr>
+            </a:lvl1pPr>
+          </a:lstStyle>
+          <a:p>
+            <a:pPr algn="l"/>
+            <a:fld id="{F7021451-1387-4CA6-816F-3879F97B5CBC}" type="slidenum">
+              <a:rPr b="0" lang="en-US"/>
+              <a:t>8</a:t>
+            </a:fld>
+            <a:endParaRPr lang="en-US"/>
           </a:p>
         </p:txBody>
       </p:sp>
@@ -9261,13 +8991,6 @@
 <file path=ppt/slides/slide9.xml><?xml version="1.0" encoding="utf-8"?>
 <p:sld xmlns:a="http://schemas.openxmlformats.org/drawingml/2006/main" xmlns:r="http://schemas.openxmlformats.org/officeDocument/2006/relationships" xmlns:p="http://schemas.openxmlformats.org/presentationml/2006/main">
   <p:cSld name="Slide 9">
-    <p:bg>
-      <p:bgPr>
-        <a:solidFill>
-          <a:srgbClr val="1A1A1A"/>
-        </a:solidFill>
-      </p:bgPr>
-    </p:bg>
     <p:spTree>
       <p:nvGrpSpPr>
         <p:cNvPr id="1" name=""/>
@@ -9362,109 +9085,7 @@
       </p:sp>
       <p:sp>
         <p:nvSpPr>
-          <p:cNvPr id="4" name="Text 2"/>
-          <p:cNvSpPr txBox="1"/>
-          <p:nvPr/>
-        </p:nvSpPr>
-        <p:spPr>
-          <a:xfrm>
-            <a:off x="457200" y="4832604"/>
-            <a:ext cx="365760" cy="182880"/>
-          </a:xfrm>
-          <a:prstGeom prst="rect">
-            <a:avLst/>
-          </a:prstGeom>
-          <a:noFill/>
-          <a:ln/>
-        </p:spPr>
-        <p:txBody>
-          <a:bodyPr wrap="square" lIns="0" tIns="0" rIns="0" bIns="0" rtlCol="0" anchor="t"/>
-          <a:lstStyle/>
-          <a:p>
-            <a:pPr indent="0" marL="0">
-              <a:buNone/>
-            </a:pPr>
-            <a:r>
-              <a:rPr lang="en-US" sz="800" dirty="0">
-                <a:solidFill>
-                  <a:srgbClr val="7E7E7E"/>
-                </a:solidFill>
-                <a:latin typeface="Poppins SemiBold" pitchFamily="34" charset="0"/>
-                <a:ea typeface="Poppins SemiBold" pitchFamily="34" charset="-122"/>
-                <a:cs typeface="Poppins SemiBold" pitchFamily="34" charset="-120"/>
-              </a:rPr>
-              <a:t>9</a:t>
-            </a:r>
-            <a:endParaRPr lang="en-US" sz="800" dirty="0"/>
-          </a:p>
-        </p:txBody>
-      </p:sp>
-      <p:sp>
-        <p:nvSpPr>
-          <p:cNvPr id="5" name="Text 3"/>
-          <p:cNvSpPr txBox="1"/>
-          <p:nvPr/>
-        </p:nvSpPr>
-        <p:spPr>
-          <a:xfrm>
-            <a:off x="868680" y="4832604"/>
-            <a:ext cx="5486400" cy="182880"/>
-          </a:xfrm>
-          <a:prstGeom prst="rect">
-            <a:avLst/>
-          </a:prstGeom>
-          <a:noFill/>
-          <a:ln/>
-        </p:spPr>
-        <p:txBody>
-          <a:bodyPr wrap="square" lIns="0" tIns="0" rIns="0" bIns="0" rtlCol="0" anchor="t"/>
-          <a:lstStyle/>
-          <a:p>
-            <a:pPr indent="0" marL="0">
-              <a:buNone/>
-            </a:pPr>
-            <a:r>
-              <a:rPr lang="en-US" sz="700" dirty="0">
-                <a:solidFill>
-                  <a:srgbClr val="7E7E7E"/>
-                </a:solidFill>
-                <a:latin typeface="Poppins" pitchFamily="34" charset="0"/>
-                <a:ea typeface="Poppins" pitchFamily="34" charset="-122"/>
-                <a:cs typeface="Poppins" pitchFamily="34" charset="-120"/>
-              </a:rPr>
-              <a:t>Sabio × DICK'S  ·  Proactive point of view for Zenith  ·  Confidential</a:t>
-            </a:r>
-            <a:endParaRPr lang="en-US" sz="700" dirty="0"/>
-          </a:p>
-        </p:txBody>
-      </p:sp>
-      <p:pic>
-        <p:nvPicPr>
-          <p:cNvPr id="6" name="Image 0" descr="/home/claude/benjaminbring-cloud/sabio-deck-builders-/assets/sabio-logo-white-sm.png">    </p:cNvPr>
-          <p:cNvPicPr>
-            <a:picLocks noChangeAspect="1"/>
-          </p:cNvPicPr>
-          <p:nvPr/>
-        </p:nvPicPr>
-        <p:blipFill>
-          <a:blip r:embed="rId1"/>
-          <a:stretch>
-            <a:fillRect/>
-          </a:stretch>
-        </p:blipFill>
-        <p:spPr>
-          <a:xfrm>
-            <a:off x="8028432" y="4805172"/>
-            <a:ext cx="647572" cy="155448"/>
-          </a:xfrm>
-          <a:prstGeom prst="rect">
-            <a:avLst/>
-          </a:prstGeom>
-        </p:spPr>
-      </p:pic>
-      <p:sp>
-        <p:nvSpPr>
-          <p:cNvPr id="7" name="Shape 4"/>
+          <p:cNvPr id="4" name="Shape 2"/>
           <p:cNvSpPr/>
           <p:nvPr/>
         </p:nvSpPr>
@@ -9489,7 +9110,7 @@
       </p:sp>
       <p:sp>
         <p:nvSpPr>
-          <p:cNvPr id="8" name="Text 5"/>
+          <p:cNvPr id="5" name="Text 3"/>
           <p:cNvSpPr txBox="1"/>
           <p:nvPr/>
         </p:nvSpPr>
@@ -9528,7 +9149,7 @@
       </p:sp>
       <p:sp>
         <p:nvSpPr>
-          <p:cNvPr id="9" name="Text 6"/>
+          <p:cNvPr id="6" name="Text 4"/>
           <p:cNvSpPr txBox="1"/>
           <p:nvPr/>
         </p:nvSpPr>
@@ -9567,7 +9188,7 @@
       </p:sp>
       <p:sp>
         <p:nvSpPr>
-          <p:cNvPr id="10" name="Text 7"/>
+          <p:cNvPr id="7" name="Text 5"/>
           <p:cNvSpPr txBox="1"/>
           <p:nvPr/>
         </p:nvSpPr>
@@ -9606,7 +9227,7 @@
       </p:sp>
       <p:sp>
         <p:nvSpPr>
-          <p:cNvPr id="11" name="Shape 8"/>
+          <p:cNvPr id="8" name="Shape 6"/>
           <p:cNvSpPr/>
           <p:nvPr/>
         </p:nvSpPr>
@@ -9631,7 +9252,7 @@
       </p:sp>
       <p:sp>
         <p:nvSpPr>
-          <p:cNvPr id="12" name="Text 9"/>
+          <p:cNvPr id="9" name="Text 7"/>
           <p:cNvSpPr txBox="1"/>
           <p:nvPr/>
         </p:nvSpPr>
@@ -9670,7 +9291,7 @@
       </p:sp>
       <p:sp>
         <p:nvSpPr>
-          <p:cNvPr id="13" name="Shape 10"/>
+          <p:cNvPr id="10" name="Shape 8"/>
           <p:cNvSpPr/>
           <p:nvPr/>
         </p:nvSpPr>
@@ -9695,7 +9316,7 @@
       </p:sp>
       <p:sp>
         <p:nvSpPr>
-          <p:cNvPr id="14" name="Text 11"/>
+          <p:cNvPr id="11" name="Text 9"/>
           <p:cNvSpPr txBox="1"/>
           <p:nvPr/>
         </p:nvSpPr>
@@ -9734,7 +9355,7 @@
       </p:sp>
       <p:sp>
         <p:nvSpPr>
-          <p:cNvPr id="15" name="Text 12"/>
+          <p:cNvPr id="12" name="Text 10"/>
           <p:cNvSpPr txBox="1"/>
           <p:nvPr/>
         </p:nvSpPr>
@@ -9773,7 +9394,7 @@
       </p:sp>
       <p:sp>
         <p:nvSpPr>
-          <p:cNvPr id="16" name="Text 13"/>
+          <p:cNvPr id="13" name="Text 11"/>
           <p:cNvSpPr txBox="1"/>
           <p:nvPr/>
         </p:nvSpPr>
@@ -9812,7 +9433,7 @@
       </p:sp>
       <p:sp>
         <p:nvSpPr>
-          <p:cNvPr id="17" name="Shape 14"/>
+          <p:cNvPr id="14" name="Shape 12"/>
           <p:cNvSpPr/>
           <p:nvPr/>
         </p:nvSpPr>
@@ -9837,7 +9458,7 @@
       </p:sp>
       <p:sp>
         <p:nvSpPr>
-          <p:cNvPr id="18" name="Text 15"/>
+          <p:cNvPr id="15" name="Text 13"/>
           <p:cNvSpPr txBox="1"/>
           <p:nvPr/>
         </p:nvSpPr>
@@ -9876,7 +9497,7 @@
       </p:sp>
       <p:sp>
         <p:nvSpPr>
-          <p:cNvPr id="19" name="Shape 16"/>
+          <p:cNvPr id="16" name="Shape 14"/>
           <p:cNvSpPr/>
           <p:nvPr/>
         </p:nvSpPr>
@@ -9901,7 +9522,7 @@
       </p:sp>
       <p:sp>
         <p:nvSpPr>
-          <p:cNvPr id="20" name="Text 17"/>
+          <p:cNvPr id="17" name="Text 15"/>
           <p:cNvSpPr txBox="1"/>
           <p:nvPr/>
         </p:nvSpPr>
@@ -9940,7 +9561,7 @@
       </p:sp>
       <p:sp>
         <p:nvSpPr>
-          <p:cNvPr id="21" name="Text 18"/>
+          <p:cNvPr id="18" name="Text 16"/>
           <p:cNvSpPr txBox="1"/>
           <p:nvPr/>
         </p:nvSpPr>
@@ -9979,7 +9600,7 @@
       </p:sp>
       <p:sp>
         <p:nvSpPr>
-          <p:cNvPr id="22" name="Text 19"/>
+          <p:cNvPr id="19" name="Text 17"/>
           <p:cNvSpPr txBox="1"/>
           <p:nvPr/>
         </p:nvSpPr>
@@ -10018,7 +9639,7 @@
       </p:sp>
       <p:sp>
         <p:nvSpPr>
-          <p:cNvPr id="23" name="Shape 20"/>
+          <p:cNvPr id="20" name="Shape 18"/>
           <p:cNvSpPr/>
           <p:nvPr/>
         </p:nvSpPr>
@@ -10043,7 +9664,7 @@
       </p:sp>
       <p:sp>
         <p:nvSpPr>
-          <p:cNvPr id="24" name="Text 21"/>
+          <p:cNvPr id="21" name="Text 19"/>
           <p:cNvSpPr txBox="1"/>
           <p:nvPr/>
         </p:nvSpPr>
@@ -10082,7 +9703,7 @@
       </p:sp>
       <p:sp>
         <p:nvSpPr>
-          <p:cNvPr id="25" name="Text 22"/>
+          <p:cNvPr id="22" name="Text 20"/>
           <p:cNvSpPr txBox="1"/>
           <p:nvPr/>
         </p:nvSpPr>
@@ -10116,6 +9737,54 @@
               <a:t>Happy to walk the team through it this week. Please LMK what else would help.</a:t>
             </a:r>
             <a:endParaRPr lang="en-US" sz="950" dirty="0"/>
+          </a:p>
+        </p:txBody>
+      </p:sp>
+      <p:sp>
+        <p:nvSpPr>
+          <p:cNvPr id="25" name="Slide Number Placeholder 0"/>
+          <p:cNvSpPr>
+            <a:spLocks noGrp="1"/>
+          </p:cNvSpPr>
+          <p:nvPr>
+            <p:ph type="sldNum" sz="quarter" idx="4294967295"/>
+          </p:nvPr>
+        </p:nvSpPr>
+        <p:spPr>
+          <a:xfrm>
+            <a:off x="457200" y="4832604"/>
+            <a:ext cx="365760" cy="182880"/>
+          </a:xfrm>
+          <a:prstGeom prst="rect">
+            <a:avLst/>
+          </a:prstGeom>
+          <a:extLst>
+            <a:ext uri="{C572A759-6A51-4108-AA02-DFA0A04FC94B}">
+              <ma14:wrappingTextBoxFlag xmlns:ma14="http://schemas.microsoft.com/office/mac/drawingml/2011/main" val="0"/>
+            </a:ext>
+          </a:extLst>
+        </p:spPr>
+        <p:txBody>
+          <a:bodyPr lIns="0" tIns="0" rIns="0" bIns="0"/>
+          <a:lstStyle>
+            <a:lvl1pPr>
+              <a:defRPr sz="800">
+                <a:solidFill>
+                  <a:srgbClr val="7E7E7E"/>
+                </a:solidFill>
+                <a:latin typeface="Poppins SemiBold"/>
+                <a:ea typeface="Poppins SemiBold"/>
+                <a:cs typeface="Poppins SemiBold"/>
+              </a:defRPr>
+            </a:lvl1pPr>
+          </a:lstStyle>
+          <a:p>
+            <a:pPr algn="l"/>
+            <a:fld id="{F7021451-1387-4CA6-816F-3879F97B5CBC}" type="slidenum">
+              <a:rPr b="0" lang="en-US"/>
+              <a:t>9</a:t>
+            </a:fld>
+            <a:endParaRPr lang="en-US"/>
           </a:p>
         </p:txBody>
       </p:sp>

</xml_diff>